<commit_message>
topic 08 and proj dev
</commit_message>
<xml_diff>
--- a/topic08-higher-order-functions/unit-08a-lectures/talk-1/a-higher-order-functions.pptx
+++ b/topic08-higher-order-functions/unit-08a-lectures/talk-1/a-higher-order-functions.pptx
@@ -560,10 +560,10 @@
           </a:ln>
           <a:extLst>
             <a:ext uri="{FAA26D3D-D897-4be2-8F04-BA451C77F1D7}">
-              <ma14:placeholderFlag xmlns:ma14="http://schemas.microsoft.com/office/mac/drawingml/2011/main" xmlns="" val="1"/>
+              <ma14:placeholderFlag xmlns="" xmlns:ma14="http://schemas.microsoft.com/office/mac/drawingml/2011/main" val="1"/>
             </a:ext>
             <a:ext uri="{909E8E84-426E-40dd-AFC4-6F175D3DCCD1}">
-              <a14:hiddenFill xmlns:a14="http://schemas.microsoft.com/office/drawing/2010/main" xmlns="">
+              <a14:hiddenFill xmlns="" xmlns:a14="http://schemas.microsoft.com/office/drawing/2010/main">
                 <a:solidFill>
                   <a:srgbClr val="FFFFFF"/>
                 </a:solidFill>
@@ -911,14 +911,14 @@
           <a:ln w="9525"/>
           <a:extLst>
             <a:ext uri="{909E8E84-426E-40dd-AFC4-6F175D3DCCD1}">
-              <a14:hiddenFill xmlns:a14="http://schemas.microsoft.com/office/drawing/2010/main" xmlns="">
+              <a14:hiddenFill xmlns="" xmlns:a14="http://schemas.microsoft.com/office/drawing/2010/main">
                 <a:solidFill>
                   <a:srgbClr val="FFFFFF"/>
                 </a:solidFill>
               </a14:hiddenFill>
             </a:ext>
             <a:ext uri="{91240B29-F687-4f45-9708-019B960494DF}">
-              <a14:hiddenLine xmlns:a14="http://schemas.microsoft.com/office/drawing/2010/main" xmlns="" w="12700" cap="sq">
+              <a14:hiddenLine xmlns="" xmlns:a14="http://schemas.microsoft.com/office/drawing/2010/main" w="12700" cap="sq">
                 <a:solidFill>
                   <a:srgbClr val="000000"/>
                 </a:solidFill>
@@ -1082,17 +1082,17 @@
           <a:ln w="9525"/>
           <a:extLst>
             <a:ext uri="{FAA26D3D-D897-4be2-8F04-BA451C77F1D7}">
-              <ma14:placeholderFlag xmlns:ma14="http://schemas.microsoft.com/office/mac/drawingml/2011/main" xmlns="" val="1"/>
+              <ma14:placeholderFlag xmlns="" xmlns:ma14="http://schemas.microsoft.com/office/mac/drawingml/2011/main" val="1"/>
             </a:ext>
             <a:ext uri="{909E8E84-426E-40dd-AFC4-6F175D3DCCD1}">
-              <a14:hiddenFill xmlns:a14="http://schemas.microsoft.com/office/drawing/2010/main" xmlns="">
+              <a14:hiddenFill xmlns="" xmlns:a14="http://schemas.microsoft.com/office/drawing/2010/main">
                 <a:solidFill>
                   <a:srgbClr val="FFFFFF"/>
                 </a:solidFill>
               </a14:hiddenFill>
             </a:ext>
             <a:ext uri="{91240B29-F687-4f45-9708-019B960494DF}">
-              <a14:hiddenLine xmlns:a14="http://schemas.microsoft.com/office/drawing/2010/main" xmlns="" w="12700" cap="sq">
+              <a14:hiddenLine xmlns="" xmlns:a14="http://schemas.microsoft.com/office/drawing/2010/main" w="12700" cap="sq">
                 <a:solidFill>
                   <a:srgbClr val="000000"/>
                 </a:solidFill>
@@ -1401,7 +1401,7 @@
             <a:fld id="{08B9EBBA-996F-894A-B54A-D6246ED52CEA}" type="datetimeFigureOut">
               <a:rPr lang="en-US" smtClean="0"/>
               <a:pPr/>
-              <a:t>3/19/25</a:t>
+              <a:t>3/7/26</a:t>
             </a:fld>
             <a:endParaRPr lang="en-US" dirty="0"/>
           </a:p>
@@ -1823,7 +1823,7 @@
             <a:fld id="{09B482E8-6E0E-1B4F-B1FD-C69DB9E858D9}" type="datetimeFigureOut">
               <a:rPr lang="en-US" smtClean="0"/>
               <a:pPr/>
-              <a:t>3/19/25</a:t>
+              <a:t>3/7/26</a:t>
             </a:fld>
             <a:endParaRPr lang="en-US" dirty="0"/>
           </a:p>
@@ -2167,7 +2167,7 @@
             <a:fld id="{09B482E8-6E0E-1B4F-B1FD-C69DB9E858D9}" type="datetimeFigureOut">
               <a:rPr lang="en-US" smtClean="0"/>
               <a:pPr/>
-              <a:t>3/19/25</a:t>
+              <a:t>3/7/26</a:t>
             </a:fld>
             <a:endParaRPr lang="en-US" dirty="0"/>
           </a:p>
@@ -2580,7 +2580,7 @@
             <a:fld id="{09B482E8-6E0E-1B4F-B1FD-C69DB9E858D9}" type="datetimeFigureOut">
               <a:rPr lang="en-US" smtClean="0"/>
               <a:pPr/>
-              <a:t>3/19/25</a:t>
+              <a:t>3/7/26</a:t>
             </a:fld>
             <a:endParaRPr lang="en-US" dirty="0"/>
           </a:p>
@@ -3156,7 +3156,7 @@
             <a:fld id="{09B482E8-6E0E-1B4F-B1FD-C69DB9E858D9}" type="datetimeFigureOut">
               <a:rPr lang="en-US" smtClean="0"/>
               <a:pPr/>
-              <a:t>3/19/25</a:t>
+              <a:t>3/7/26</a:t>
             </a:fld>
             <a:endParaRPr lang="en-US" dirty="0"/>
           </a:p>
@@ -3845,7 +3845,7 @@
             <a:fld id="{09B482E8-6E0E-1B4F-B1FD-C69DB9E858D9}" type="datetimeFigureOut">
               <a:rPr lang="en-US" smtClean="0"/>
               <a:pPr/>
-              <a:t>3/19/25</a:t>
+              <a:t>3/7/26</a:t>
             </a:fld>
             <a:endParaRPr lang="en-US" dirty="0"/>
           </a:p>
@@ -4766,7 +4766,7 @@
             <a:fld id="{09B482E8-6E0E-1B4F-B1FD-C69DB9E858D9}" type="datetimeFigureOut">
               <a:rPr lang="en-US" smtClean="0"/>
               <a:pPr/>
-              <a:t>3/19/25</a:t>
+              <a:t>3/7/26</a:t>
             </a:fld>
             <a:endParaRPr lang="en-US" dirty="0"/>
           </a:p>
@@ -5087,7 +5087,7 @@
             <a:fld id="{09B482E8-6E0E-1B4F-B1FD-C69DB9E858D9}" type="datetimeFigureOut">
               <a:rPr lang="en-US" smtClean="0"/>
               <a:pPr/>
-              <a:t>3/19/25</a:t>
+              <a:t>3/7/26</a:t>
             </a:fld>
             <a:endParaRPr lang="en-US" dirty="0"/>
           </a:p>
@@ -5358,7 +5358,7 @@
             <a:fld id="{09B482E8-6E0E-1B4F-B1FD-C69DB9E858D9}" type="datetimeFigureOut">
               <a:rPr lang="en-US" smtClean="0"/>
               <a:pPr/>
-              <a:t>3/19/25</a:t>
+              <a:t>3/7/26</a:t>
             </a:fld>
             <a:endParaRPr lang="en-US" dirty="0"/>
           </a:p>
@@ -5688,7 +5688,7 @@
             <a:fld id="{09B482E8-6E0E-1B4F-B1FD-C69DB9E858D9}" type="datetimeFigureOut">
               <a:rPr lang="en-US" smtClean="0"/>
               <a:pPr/>
-              <a:t>3/19/25</a:t>
+              <a:t>3/7/26</a:t>
             </a:fld>
             <a:endParaRPr lang="en-US" dirty="0"/>
           </a:p>
@@ -6084,7 +6084,7 @@
             <a:fld id="{8DFA1846-DA80-1C48-A609-854EA85C59AD}" type="datetimeFigureOut">
               <a:rPr lang="en-US" smtClean="0"/>
               <a:pPr/>
-              <a:t>3/19/25</a:t>
+              <a:t>3/7/26</a:t>
             </a:fld>
             <a:endParaRPr lang="en-US" dirty="0"/>
           </a:p>
@@ -6467,7 +6467,7 @@
             <a:fld id="{09B482E8-6E0E-1B4F-B1FD-C69DB9E858D9}" type="datetimeFigureOut">
               <a:rPr lang="en-US" smtClean="0"/>
               <a:pPr/>
-              <a:t>3/19/25</a:t>
+              <a:t>3/7/26</a:t>
             </a:fld>
             <a:endParaRPr lang="en-US" dirty="0"/>
           </a:p>
@@ -6980,7 +6980,7 @@
             <a:fld id="{09B482E8-6E0E-1B4F-B1FD-C69DB9E858D9}" type="datetimeFigureOut">
               <a:rPr lang="en-US" smtClean="0"/>
               <a:pPr/>
-              <a:t>3/19/25</a:t>
+              <a:t>3/7/26</a:t>
             </a:fld>
             <a:endParaRPr lang="en-US" dirty="0"/>
           </a:p>
@@ -7244,7 +7244,7 @@
             <a:fld id="{F13A34C8-038E-2045-AF43-DF7DBB8E0E9E}" type="datetimeFigureOut">
               <a:rPr lang="en-US" smtClean="0"/>
               <a:pPr/>
-              <a:t>3/19/25</a:t>
+              <a:t>3/7/26</a:t>
             </a:fld>
             <a:endParaRPr lang="en-US" dirty="0"/>
           </a:p>
@@ -7395,6 +7395,13 @@
             <a:schemeClr val="lt1"/>
           </a:fontRef>
         </p:style>
+        <p:txBody>
+          <a:bodyPr/>
+          <a:lstStyle/>
+          <a:p>
+            <a:endParaRPr lang="en-US"/>
+          </a:p>
+        </p:txBody>
       </p:sp>
       <p:sp>
         <p:nvSpPr>
@@ -7414,7 +7421,7 @@
             <a:fld id="{8818C68F-D26B-8F47-958C-23B49CF8A634}" type="datetimeFigureOut">
               <a:rPr lang="en-US" smtClean="0"/>
               <a:pPr/>
-              <a:t>3/19/25</a:t>
+              <a:t>3/7/26</a:t>
             </a:fld>
             <a:endParaRPr lang="en-US" dirty="0"/>
           </a:p>
@@ -7811,7 +7818,7 @@
             <a:fld id="{09B482E8-6E0E-1B4F-B1FD-C69DB9E858D9}" type="datetimeFigureOut">
               <a:rPr lang="en-US" smtClean="0"/>
               <a:pPr/>
-              <a:t>3/19/25</a:t>
+              <a:t>3/7/26</a:t>
             </a:fld>
             <a:endParaRPr lang="en-US" dirty="0"/>
           </a:p>
@@ -8227,7 +8234,7 @@
             <a:fld id="{09B482E8-6E0E-1B4F-B1FD-C69DB9E858D9}" type="datetimeFigureOut">
               <a:rPr lang="en-US" smtClean="0"/>
               <a:pPr/>
-              <a:t>3/19/25</a:t>
+              <a:t>3/7/26</a:t>
             </a:fld>
             <a:endParaRPr lang="en-US" dirty="0"/>
           </a:p>
@@ -8478,7 +8485,7 @@
             <a:fld id="{09B482E8-6E0E-1B4F-B1FD-C69DB9E858D9}" type="datetimeFigureOut">
               <a:rPr lang="en-US" smtClean="0"/>
               <a:pPr/>
-              <a:t>3/19/25</a:t>
+              <a:t>3/7/26</a:t>
             </a:fld>
             <a:endParaRPr lang="en-US" dirty="0"/>
           </a:p>
@@ -8916,14 +8923,14 @@
           <a:ln/>
           <a:extLst>
             <a:ext uri="{909E8E84-426E-40dd-AFC4-6F175D3DCCD1}">
-              <a14:hiddenFill xmlns:a14="http://schemas.microsoft.com/office/drawing/2010/main" xmlns="">
+              <a14:hiddenFill xmlns="" xmlns:a14="http://schemas.microsoft.com/office/drawing/2010/main">
                 <a:solidFill>
                   <a:srgbClr val="FFFFFF"/>
                 </a:solidFill>
               </a14:hiddenFill>
             </a:ext>
             <a:ext uri="{91240B29-F687-4f45-9708-019B960494DF}">
-              <a14:hiddenLine xmlns:a14="http://schemas.microsoft.com/office/drawing/2010/main" xmlns="" w="9525">
+              <a14:hiddenLine xmlns="" xmlns:a14="http://schemas.microsoft.com/office/drawing/2010/main" w="9525">
                 <a:solidFill>
                   <a:srgbClr val="000000"/>
                 </a:solidFill>
@@ -9076,14 +9083,14 @@
           </a:ln>
           <a:extLst>
             <a:ext uri="{909E8E84-426E-40dd-AFC4-6F175D3DCCD1}">
-              <a14:hiddenFill xmlns:a14="http://schemas.microsoft.com/office/drawing/2010/main" xmlns="">
+              <a14:hiddenFill xmlns="" xmlns:a14="http://schemas.microsoft.com/office/drawing/2010/main">
                 <a:solidFill>
                   <a:srgbClr val="FFFFFF"/>
                 </a:solidFill>
               </a14:hiddenFill>
             </a:ext>
             <a:ext uri="{91240B29-F687-4f45-9708-019B960494DF}">
-              <a14:hiddenLine xmlns:a14="http://schemas.microsoft.com/office/drawing/2010/main" xmlns="" w="9525">
+              <a14:hiddenLine xmlns="" xmlns:a14="http://schemas.microsoft.com/office/drawing/2010/main" w="9525">
                 <a:solidFill>
                   <a:srgbClr val="000000"/>
                 </a:solidFill>
@@ -9242,14 +9249,14 @@
           </a:ln>
           <a:extLst>
             <a:ext uri="{909E8E84-426E-40dd-AFC4-6F175D3DCCD1}">
-              <a14:hiddenFill xmlns:a14="http://schemas.microsoft.com/office/drawing/2010/main" xmlns="">
+              <a14:hiddenFill xmlns="" xmlns:a14="http://schemas.microsoft.com/office/drawing/2010/main">
                 <a:solidFill>
                   <a:srgbClr val="FFFFFF"/>
                 </a:solidFill>
               </a14:hiddenFill>
             </a:ext>
             <a:ext uri="{91240B29-F687-4f45-9708-019B960494DF}">
-              <a14:hiddenLine xmlns:a14="http://schemas.microsoft.com/office/drawing/2010/main" xmlns="" w="9525">
+              <a14:hiddenLine xmlns="" xmlns:a14="http://schemas.microsoft.com/office/drawing/2010/main" w="9525">
                 <a:solidFill>
                   <a:srgbClr val="000000"/>
                 </a:solidFill>
@@ -9266,12 +9273,8 @@
           <a:p>
             <a:pPr algn="ctr"/>
             <a:r>
-              <a:rPr kumimoji="1" lang="en-US" sz="3200"/>
-              <a:t>Chapter 8.1 </a:t>
-            </a:r>
-            <a:r>
               <a:rPr kumimoji="1" lang="en-US" sz="3200" dirty="0"/>
-              <a:t>- Higher-Order Functions</a:t>
+              <a:t>Topic 8.1 - Higher-Order Functions</a:t>
             </a:r>
           </a:p>
         </p:txBody>
@@ -9311,14 +9314,14 @@
           </a:ln>
           <a:extLst>
             <a:ext uri="{909E8E84-426E-40dd-AFC4-6F175D3DCCD1}">
-              <a14:hiddenFill xmlns:a14="http://schemas.microsoft.com/office/drawing/2010/main" xmlns="">
+              <a14:hiddenFill xmlns="" xmlns:a14="http://schemas.microsoft.com/office/drawing/2010/main">
                 <a:solidFill>
                   <a:srgbClr val="FFFFFF"/>
                 </a:solidFill>
               </a14:hiddenFill>
             </a:ext>
             <a:ext uri="{91240B29-F687-4f45-9708-019B960494DF}">
-              <a14:hiddenLine xmlns:a14="http://schemas.microsoft.com/office/drawing/2010/main" xmlns="" w="9525">
+              <a14:hiddenLine xmlns="" xmlns:a14="http://schemas.microsoft.com/office/drawing/2010/main" w="9525">
                 <a:solidFill>
                   <a:srgbClr val="000000"/>
                 </a:solidFill>
@@ -9370,14 +9373,14 @@
           <a:ln/>
           <a:extLst>
             <a:ext uri="{909E8E84-426E-40dd-AFC4-6F175D3DCCD1}">
-              <a14:hiddenFill xmlns:a14="http://schemas.microsoft.com/office/drawing/2010/main" xmlns="">
+              <a14:hiddenFill xmlns="" xmlns:a14="http://schemas.microsoft.com/office/drawing/2010/main">
                 <a:solidFill>
                   <a:srgbClr val="FFFFFF"/>
                 </a:solidFill>
               </a14:hiddenFill>
             </a:ext>
             <a:ext uri="{91240B29-F687-4f45-9708-019B960494DF}">
-              <a14:hiddenLine xmlns:a14="http://schemas.microsoft.com/office/drawing/2010/main" xmlns="" w="9525">
+              <a14:hiddenLine xmlns="" xmlns:a14="http://schemas.microsoft.com/office/drawing/2010/main" w="9525">
                 <a:solidFill>
                   <a:srgbClr val="000000"/>
                 </a:solidFill>
@@ -9530,14 +9533,14 @@
           </a:ln>
           <a:extLst>
             <a:ext uri="{909E8E84-426E-40dd-AFC4-6F175D3DCCD1}">
-              <a14:hiddenFill xmlns:a14="http://schemas.microsoft.com/office/drawing/2010/main" xmlns="">
+              <a14:hiddenFill xmlns="" xmlns:a14="http://schemas.microsoft.com/office/drawing/2010/main">
                 <a:solidFill>
                   <a:srgbClr val="FFFFFF"/>
                 </a:solidFill>
               </a14:hiddenFill>
             </a:ext>
             <a:ext uri="{91240B29-F687-4f45-9708-019B960494DF}">
-              <a14:hiddenLine xmlns:a14="http://schemas.microsoft.com/office/drawing/2010/main" xmlns="" w="12700" cap="sq">
+              <a14:hiddenLine xmlns="" xmlns:a14="http://schemas.microsoft.com/office/drawing/2010/main" w="12700" cap="sq">
                 <a:solidFill>
                   <a:srgbClr val="000000"/>
                 </a:solidFill>
@@ -9720,7 +9723,7 @@
           </a:ln>
           <a:extLst>
             <a:ext uri="{91240B29-F687-4f45-9708-019B960494DF}">
-              <a14:hiddenLine xmlns:a14="http://schemas.microsoft.com/office/drawing/2010/main" xmlns="" w="12700" cap="sq">
+              <a14:hiddenLine xmlns="" xmlns:a14="http://schemas.microsoft.com/office/drawing/2010/main" w="12700" cap="sq">
                 <a:solidFill>
                   <a:srgbClr val="000000"/>
                 </a:solidFill>
@@ -10215,14 +10218,14 @@
           <a:ln/>
           <a:extLst>
             <a:ext uri="{909E8E84-426E-40dd-AFC4-6F175D3DCCD1}">
-              <a14:hiddenFill xmlns:a14="http://schemas.microsoft.com/office/drawing/2010/main" xmlns="">
+              <a14:hiddenFill xmlns="" xmlns:a14="http://schemas.microsoft.com/office/drawing/2010/main">
                 <a:solidFill>
                   <a:srgbClr val="FFFFFF"/>
                 </a:solidFill>
               </a14:hiddenFill>
             </a:ext>
             <a:ext uri="{91240B29-F687-4f45-9708-019B960494DF}">
-              <a14:hiddenLine xmlns:a14="http://schemas.microsoft.com/office/drawing/2010/main" xmlns="" w="9525">
+              <a14:hiddenLine xmlns="" xmlns:a14="http://schemas.microsoft.com/office/drawing/2010/main" w="9525">
                 <a:solidFill>
                   <a:srgbClr val="000000"/>
                 </a:solidFill>
@@ -10375,14 +10378,14 @@
           </a:ln>
           <a:extLst>
             <a:ext uri="{909E8E84-426E-40dd-AFC4-6F175D3DCCD1}">
-              <a14:hiddenFill xmlns:a14="http://schemas.microsoft.com/office/drawing/2010/main" xmlns="">
+              <a14:hiddenFill xmlns="" xmlns:a14="http://schemas.microsoft.com/office/drawing/2010/main">
                 <a:solidFill>
                   <a:srgbClr val="FFFFFF"/>
                 </a:solidFill>
               </a14:hiddenFill>
             </a:ext>
             <a:ext uri="{91240B29-F687-4f45-9708-019B960494DF}">
-              <a14:hiddenLine xmlns:a14="http://schemas.microsoft.com/office/drawing/2010/main" xmlns="" w="12700" cap="sq">
+              <a14:hiddenLine xmlns="" xmlns:a14="http://schemas.microsoft.com/office/drawing/2010/main" w="12700" cap="sq">
                 <a:solidFill>
                   <a:srgbClr val="000000"/>
                 </a:solidFill>
@@ -10541,7 +10544,7 @@
           </a:ln>
           <a:extLst>
             <a:ext uri="{91240B29-F687-4f45-9708-019B960494DF}">
-              <a14:hiddenLine xmlns:a14="http://schemas.microsoft.com/office/drawing/2010/main" xmlns="" w="12700" cap="sq">
+              <a14:hiddenLine xmlns="" xmlns:a14="http://schemas.microsoft.com/office/drawing/2010/main" w="12700" cap="sq">
                 <a:solidFill>
                   <a:srgbClr val="000000"/>
                 </a:solidFill>
@@ -10848,14 +10851,14 @@
           </a:ln>
           <a:extLst>
             <a:ext uri="{909E8E84-426E-40dd-AFC4-6F175D3DCCD1}">
-              <a14:hiddenFill xmlns:a14="http://schemas.microsoft.com/office/drawing/2010/main" xmlns="">
+              <a14:hiddenFill xmlns="" xmlns:a14="http://schemas.microsoft.com/office/drawing/2010/main">
                 <a:solidFill>
                   <a:srgbClr val="FFFFFF"/>
                 </a:solidFill>
               </a14:hiddenFill>
             </a:ext>
             <a:ext uri="{91240B29-F687-4f45-9708-019B960494DF}">
-              <a14:hiddenLine xmlns:a14="http://schemas.microsoft.com/office/drawing/2010/main" xmlns="" w="12700" cap="sq">
+              <a14:hiddenLine xmlns="" xmlns:a14="http://schemas.microsoft.com/office/drawing/2010/main" w="12700" cap="sq">
                 <a:solidFill>
                   <a:srgbClr val="000000"/>
                 </a:solidFill>
@@ -11258,14 +11261,14 @@
           <a:ln/>
           <a:extLst>
             <a:ext uri="{909E8E84-426E-40dd-AFC4-6F175D3DCCD1}">
-              <a14:hiddenFill xmlns:a14="http://schemas.microsoft.com/office/drawing/2010/main" xmlns="">
+              <a14:hiddenFill xmlns="" xmlns:a14="http://schemas.microsoft.com/office/drawing/2010/main">
                 <a:solidFill>
                   <a:srgbClr val="FFFFFF"/>
                 </a:solidFill>
               </a14:hiddenFill>
             </a:ext>
             <a:ext uri="{91240B29-F687-4f45-9708-019B960494DF}">
-              <a14:hiddenLine xmlns:a14="http://schemas.microsoft.com/office/drawing/2010/main" xmlns="" w="9525">
+              <a14:hiddenLine xmlns="" xmlns:a14="http://schemas.microsoft.com/office/drawing/2010/main" w="9525">
                 <a:solidFill>
                   <a:srgbClr val="000000"/>
                 </a:solidFill>
@@ -11420,7 +11423,7 @@
           </a:ln>
           <a:extLst>
             <a:ext uri="{91240B29-F687-4f45-9708-019B960494DF}">
-              <a14:hiddenLine xmlns:a14="http://schemas.microsoft.com/office/drawing/2010/main" xmlns="" w="12700" cap="sq">
+              <a14:hiddenLine xmlns="" xmlns:a14="http://schemas.microsoft.com/office/drawing/2010/main" w="12700" cap="sq">
                 <a:solidFill>
                   <a:srgbClr val="000000"/>
                 </a:solidFill>
@@ -11598,7 +11601,7 @@
             </a:ln>
             <a:extLst>
               <a:ext uri="{91240B29-F687-4f45-9708-019B960494DF}">
-                <a14:hiddenLine xmlns:a14="http://schemas.microsoft.com/office/drawing/2010/main" xmlns="" w="12700" cap="sq">
+                <a14:hiddenLine xmlns="" xmlns:a14="http://schemas.microsoft.com/office/drawing/2010/main" w="12700" cap="sq">
                   <a:solidFill>
                     <a:srgbClr val="000000"/>
                   </a:solidFill>
@@ -11764,14 +11767,14 @@
             </a:ln>
             <a:extLst>
               <a:ext uri="{909E8E84-426E-40dd-AFC4-6F175D3DCCD1}">
-                <a14:hiddenFill xmlns:a14="http://schemas.microsoft.com/office/drawing/2010/main" xmlns="">
+                <a14:hiddenFill xmlns="" xmlns:a14="http://schemas.microsoft.com/office/drawing/2010/main">
                   <a:solidFill>
                     <a:srgbClr val="FFFFFF"/>
                   </a:solidFill>
                 </a14:hiddenFill>
               </a:ext>
               <a:ext uri="{91240B29-F687-4f45-9708-019B960494DF}">
-                <a14:hiddenLine xmlns:a14="http://schemas.microsoft.com/office/drawing/2010/main" xmlns="" w="12700" cap="sq">
+                <a14:hiddenLine xmlns="" xmlns:a14="http://schemas.microsoft.com/office/drawing/2010/main" w="12700" cap="sq">
                   <a:solidFill>
                     <a:srgbClr val="000000"/>
                   </a:solidFill>
@@ -11944,7 +11947,7 @@
             </a:ln>
             <a:extLst>
               <a:ext uri="{91240B29-F687-4f45-9708-019B960494DF}">
-                <a14:hiddenLine xmlns:a14="http://schemas.microsoft.com/office/drawing/2010/main" xmlns="" w="12700" cap="sq">
+                <a14:hiddenLine xmlns="" xmlns:a14="http://schemas.microsoft.com/office/drawing/2010/main" w="12700" cap="sq">
                   <a:solidFill>
                     <a:srgbClr val="000000"/>
                   </a:solidFill>
@@ -12104,14 +12107,14 @@
             </a:ln>
             <a:extLst>
               <a:ext uri="{909E8E84-426E-40dd-AFC4-6F175D3DCCD1}">
-                <a14:hiddenFill xmlns:a14="http://schemas.microsoft.com/office/drawing/2010/main" xmlns="">
+                <a14:hiddenFill xmlns="" xmlns:a14="http://schemas.microsoft.com/office/drawing/2010/main">
                   <a:solidFill>
                     <a:srgbClr val="FFFFFF"/>
                   </a:solidFill>
                 </a14:hiddenFill>
               </a:ext>
               <a:ext uri="{91240B29-F687-4f45-9708-019B960494DF}">
-                <a14:hiddenLine xmlns:a14="http://schemas.microsoft.com/office/drawing/2010/main" xmlns="" w="12700" cap="sq">
+                <a14:hiddenLine xmlns="" xmlns:a14="http://schemas.microsoft.com/office/drawing/2010/main" w="12700" cap="sq">
                   <a:solidFill>
                     <a:srgbClr val="000000"/>
                   </a:solidFill>
@@ -12284,7 +12287,7 @@
             </a:ln>
             <a:extLst>
               <a:ext uri="{91240B29-F687-4f45-9708-019B960494DF}">
-                <a14:hiddenLine xmlns:a14="http://schemas.microsoft.com/office/drawing/2010/main" xmlns="" w="12700" cap="sq">
+                <a14:hiddenLine xmlns="" xmlns:a14="http://schemas.microsoft.com/office/drawing/2010/main" w="12700" cap="sq">
                   <a:solidFill>
                     <a:srgbClr val="000000"/>
                   </a:solidFill>
@@ -12444,14 +12447,14 @@
             </a:ln>
             <a:extLst>
               <a:ext uri="{909E8E84-426E-40dd-AFC4-6F175D3DCCD1}">
-                <a14:hiddenFill xmlns:a14="http://schemas.microsoft.com/office/drawing/2010/main" xmlns="">
+                <a14:hiddenFill xmlns="" xmlns:a14="http://schemas.microsoft.com/office/drawing/2010/main">
                   <a:solidFill>
                     <a:srgbClr val="FFFFFF"/>
                   </a:solidFill>
                 </a14:hiddenFill>
               </a:ext>
               <a:ext uri="{91240B29-F687-4f45-9708-019B960494DF}">
-                <a14:hiddenLine xmlns:a14="http://schemas.microsoft.com/office/drawing/2010/main" xmlns="" w="12700" cap="sq">
+                <a14:hiddenLine xmlns="" xmlns:a14="http://schemas.microsoft.com/office/drawing/2010/main" w="12700" cap="sq">
                   <a:solidFill>
                     <a:srgbClr val="000000"/>
                   </a:solidFill>
@@ -12624,7 +12627,7 @@
             </a:ln>
             <a:extLst>
               <a:ext uri="{91240B29-F687-4f45-9708-019B960494DF}">
-                <a14:hiddenLine xmlns:a14="http://schemas.microsoft.com/office/drawing/2010/main" xmlns="" w="12700" cap="sq">
+                <a14:hiddenLine xmlns="" xmlns:a14="http://schemas.microsoft.com/office/drawing/2010/main" w="12700" cap="sq">
                   <a:solidFill>
                     <a:srgbClr val="000000"/>
                   </a:solidFill>
@@ -12784,14 +12787,14 @@
             </a:ln>
             <a:extLst>
               <a:ext uri="{909E8E84-426E-40dd-AFC4-6F175D3DCCD1}">
-                <a14:hiddenFill xmlns:a14="http://schemas.microsoft.com/office/drawing/2010/main" xmlns="">
+                <a14:hiddenFill xmlns="" xmlns:a14="http://schemas.microsoft.com/office/drawing/2010/main">
                   <a:solidFill>
                     <a:srgbClr val="FFFFFF"/>
                   </a:solidFill>
                 </a14:hiddenFill>
               </a:ext>
               <a:ext uri="{91240B29-F687-4f45-9708-019B960494DF}">
-                <a14:hiddenLine xmlns:a14="http://schemas.microsoft.com/office/drawing/2010/main" xmlns="" w="12700" cap="sq">
+                <a14:hiddenLine xmlns="" xmlns:a14="http://schemas.microsoft.com/office/drawing/2010/main" w="12700" cap="sq">
                   <a:solidFill>
                     <a:srgbClr val="000000"/>
                   </a:solidFill>
@@ -12946,14 +12949,14 @@
           </a:ln>
           <a:extLst>
             <a:ext uri="{909E8E84-426E-40dd-AFC4-6F175D3DCCD1}">
-              <a14:hiddenFill xmlns:a14="http://schemas.microsoft.com/office/drawing/2010/main" xmlns="">
+              <a14:hiddenFill xmlns="" xmlns:a14="http://schemas.microsoft.com/office/drawing/2010/main">
                 <a:solidFill>
                   <a:srgbClr val="FFFFFF"/>
                 </a:solidFill>
               </a14:hiddenFill>
             </a:ext>
             <a:ext uri="{91240B29-F687-4f45-9708-019B960494DF}">
-              <a14:hiddenLine xmlns:a14="http://schemas.microsoft.com/office/drawing/2010/main" xmlns="" w="12700" cap="sq">
+              <a14:hiddenLine xmlns="" xmlns:a14="http://schemas.microsoft.com/office/drawing/2010/main" w="12700" cap="sq">
                 <a:solidFill>
                   <a:srgbClr val="000000"/>
                 </a:solidFill>
@@ -13117,7 +13120,7 @@
           </a:ln>
           <a:extLst>
             <a:ext uri="{909E8E84-426E-40dd-AFC4-6F175D3DCCD1}">
-              <a14:hiddenFill xmlns:a14="http://schemas.microsoft.com/office/drawing/2010/main" xmlns="">
+              <a14:hiddenFill xmlns="" xmlns:a14="http://schemas.microsoft.com/office/drawing/2010/main">
                 <a:solidFill>
                   <a:srgbClr val="FFFFFF"/>
                 </a:solidFill>
@@ -13484,14 +13487,14 @@
           <a:ln/>
           <a:extLst>
             <a:ext uri="{909E8E84-426E-40dd-AFC4-6F175D3DCCD1}">
-              <a14:hiddenFill xmlns:a14="http://schemas.microsoft.com/office/drawing/2010/main" xmlns="">
+              <a14:hiddenFill xmlns="" xmlns:a14="http://schemas.microsoft.com/office/drawing/2010/main">
                 <a:solidFill>
                   <a:srgbClr val="FFFFFF"/>
                 </a:solidFill>
               </a14:hiddenFill>
             </a:ext>
             <a:ext uri="{91240B29-F687-4f45-9708-019B960494DF}">
-              <a14:hiddenLine xmlns:a14="http://schemas.microsoft.com/office/drawing/2010/main" xmlns="" w="9525">
+              <a14:hiddenLine xmlns="" xmlns:a14="http://schemas.microsoft.com/office/drawing/2010/main" w="9525">
                 <a:solidFill>
                   <a:srgbClr val="000000"/>
                 </a:solidFill>
@@ -13646,7 +13649,7 @@
           </a:ln>
           <a:extLst>
             <a:ext uri="{91240B29-F687-4f45-9708-019B960494DF}">
-              <a14:hiddenLine xmlns:a14="http://schemas.microsoft.com/office/drawing/2010/main" xmlns="" w="12700" cap="sq">
+              <a14:hiddenLine xmlns="" xmlns:a14="http://schemas.microsoft.com/office/drawing/2010/main" w="12700" cap="sq">
                 <a:solidFill>
                   <a:srgbClr val="000000"/>
                 </a:solidFill>
@@ -13824,7 +13827,7 @@
             </a:ln>
             <a:extLst>
               <a:ext uri="{91240B29-F687-4f45-9708-019B960494DF}">
-                <a14:hiddenLine xmlns:a14="http://schemas.microsoft.com/office/drawing/2010/main" xmlns="" w="12700" cap="sq">
+                <a14:hiddenLine xmlns="" xmlns:a14="http://schemas.microsoft.com/office/drawing/2010/main" w="12700" cap="sq">
                   <a:solidFill>
                     <a:srgbClr val="000000"/>
                   </a:solidFill>
@@ -13984,14 +13987,14 @@
             </a:ln>
             <a:extLst>
               <a:ext uri="{909E8E84-426E-40dd-AFC4-6F175D3DCCD1}">
-                <a14:hiddenFill xmlns:a14="http://schemas.microsoft.com/office/drawing/2010/main" xmlns="">
+                <a14:hiddenFill xmlns="" xmlns:a14="http://schemas.microsoft.com/office/drawing/2010/main">
                   <a:solidFill>
                     <a:srgbClr val="FFFFFF"/>
                   </a:solidFill>
                 </a14:hiddenFill>
               </a:ext>
               <a:ext uri="{91240B29-F687-4f45-9708-019B960494DF}">
-                <a14:hiddenLine xmlns:a14="http://schemas.microsoft.com/office/drawing/2010/main" xmlns="" w="12700" cap="sq">
+                <a14:hiddenLine xmlns="" xmlns:a14="http://schemas.microsoft.com/office/drawing/2010/main" w="12700" cap="sq">
                   <a:solidFill>
                     <a:srgbClr val="000000"/>
                   </a:solidFill>
@@ -14164,7 +14167,7 @@
             </a:ln>
             <a:extLst>
               <a:ext uri="{91240B29-F687-4f45-9708-019B960494DF}">
-                <a14:hiddenLine xmlns:a14="http://schemas.microsoft.com/office/drawing/2010/main" xmlns="" w="12700" cap="sq">
+                <a14:hiddenLine xmlns="" xmlns:a14="http://schemas.microsoft.com/office/drawing/2010/main" w="12700" cap="sq">
                   <a:solidFill>
                     <a:srgbClr val="000000"/>
                   </a:solidFill>
@@ -14324,14 +14327,14 @@
             </a:ln>
             <a:extLst>
               <a:ext uri="{909E8E84-426E-40dd-AFC4-6F175D3DCCD1}">
-                <a14:hiddenFill xmlns:a14="http://schemas.microsoft.com/office/drawing/2010/main" xmlns="">
+                <a14:hiddenFill xmlns="" xmlns:a14="http://schemas.microsoft.com/office/drawing/2010/main">
                   <a:solidFill>
                     <a:srgbClr val="FFFFFF"/>
                   </a:solidFill>
                 </a14:hiddenFill>
               </a:ext>
               <a:ext uri="{91240B29-F687-4f45-9708-019B960494DF}">
-                <a14:hiddenLine xmlns:a14="http://schemas.microsoft.com/office/drawing/2010/main" xmlns="" w="12700" cap="sq">
+                <a14:hiddenLine xmlns="" xmlns:a14="http://schemas.microsoft.com/office/drawing/2010/main" w="12700" cap="sq">
                   <a:solidFill>
                     <a:srgbClr val="000000"/>
                   </a:solidFill>
@@ -14504,7 +14507,7 @@
             </a:ln>
             <a:extLst>
               <a:ext uri="{91240B29-F687-4f45-9708-019B960494DF}">
-                <a14:hiddenLine xmlns:a14="http://schemas.microsoft.com/office/drawing/2010/main" xmlns="" w="12700" cap="sq">
+                <a14:hiddenLine xmlns="" xmlns:a14="http://schemas.microsoft.com/office/drawing/2010/main" w="12700" cap="sq">
                   <a:solidFill>
                     <a:srgbClr val="000000"/>
                   </a:solidFill>
@@ -14664,14 +14667,14 @@
             </a:ln>
             <a:extLst>
               <a:ext uri="{909E8E84-426E-40dd-AFC4-6F175D3DCCD1}">
-                <a14:hiddenFill xmlns:a14="http://schemas.microsoft.com/office/drawing/2010/main" xmlns="">
+                <a14:hiddenFill xmlns="" xmlns:a14="http://schemas.microsoft.com/office/drawing/2010/main">
                   <a:solidFill>
                     <a:srgbClr val="FFFFFF"/>
                   </a:solidFill>
                 </a14:hiddenFill>
               </a:ext>
               <a:ext uri="{91240B29-F687-4f45-9708-019B960494DF}">
-                <a14:hiddenLine xmlns:a14="http://schemas.microsoft.com/office/drawing/2010/main" xmlns="" w="12700" cap="sq">
+                <a14:hiddenLine xmlns="" xmlns:a14="http://schemas.microsoft.com/office/drawing/2010/main" w="12700" cap="sq">
                   <a:solidFill>
                     <a:srgbClr val="000000"/>
                   </a:solidFill>
@@ -14844,7 +14847,7 @@
             </a:ln>
             <a:extLst>
               <a:ext uri="{91240B29-F687-4f45-9708-019B960494DF}">
-                <a14:hiddenLine xmlns:a14="http://schemas.microsoft.com/office/drawing/2010/main" xmlns="" w="12700" cap="sq">
+                <a14:hiddenLine xmlns="" xmlns:a14="http://schemas.microsoft.com/office/drawing/2010/main" w="12700" cap="sq">
                   <a:solidFill>
                     <a:srgbClr val="000000"/>
                   </a:solidFill>
@@ -15004,14 +15007,14 @@
             </a:ln>
             <a:extLst>
               <a:ext uri="{909E8E84-426E-40dd-AFC4-6F175D3DCCD1}">
-                <a14:hiddenFill xmlns:a14="http://schemas.microsoft.com/office/drawing/2010/main" xmlns="">
+                <a14:hiddenFill xmlns="" xmlns:a14="http://schemas.microsoft.com/office/drawing/2010/main">
                   <a:solidFill>
                     <a:srgbClr val="FFFFFF"/>
                   </a:solidFill>
                 </a14:hiddenFill>
               </a:ext>
               <a:ext uri="{91240B29-F687-4f45-9708-019B960494DF}">
-                <a14:hiddenLine xmlns:a14="http://schemas.microsoft.com/office/drawing/2010/main" xmlns="" w="12700" cap="sq">
+                <a14:hiddenLine xmlns="" xmlns:a14="http://schemas.microsoft.com/office/drawing/2010/main" w="12700" cap="sq">
                   <a:solidFill>
                     <a:srgbClr val="000000"/>
                   </a:solidFill>
@@ -15166,14 +15169,14 @@
           </a:ln>
           <a:extLst>
             <a:ext uri="{909E8E84-426E-40dd-AFC4-6F175D3DCCD1}">
-              <a14:hiddenFill xmlns:a14="http://schemas.microsoft.com/office/drawing/2010/main" xmlns="">
+              <a14:hiddenFill xmlns="" xmlns:a14="http://schemas.microsoft.com/office/drawing/2010/main">
                 <a:solidFill>
                   <a:srgbClr val="FFFFFF"/>
                 </a:solidFill>
               </a14:hiddenFill>
             </a:ext>
             <a:ext uri="{91240B29-F687-4f45-9708-019B960494DF}">
-              <a14:hiddenLine xmlns:a14="http://schemas.microsoft.com/office/drawing/2010/main" xmlns="" w="12700" cap="sq">
+              <a14:hiddenLine xmlns="" xmlns:a14="http://schemas.microsoft.com/office/drawing/2010/main" w="12700" cap="sq">
                 <a:solidFill>
                   <a:srgbClr val="000000"/>
                 </a:solidFill>
@@ -15337,7 +15340,7 @@
           </a:ln>
           <a:extLst>
             <a:ext uri="{909E8E84-426E-40dd-AFC4-6F175D3DCCD1}">
-              <a14:hiddenFill xmlns:a14="http://schemas.microsoft.com/office/drawing/2010/main" xmlns="">
+              <a14:hiddenFill xmlns="" xmlns:a14="http://schemas.microsoft.com/office/drawing/2010/main">
                 <a:solidFill>
                   <a:srgbClr val="FFFFFF"/>
                 </a:solidFill>
@@ -15728,14 +15731,14 @@
           <a:ln/>
           <a:extLst>
             <a:ext uri="{909E8E84-426E-40dd-AFC4-6F175D3DCCD1}">
-              <a14:hiddenFill xmlns:a14="http://schemas.microsoft.com/office/drawing/2010/main" xmlns="">
+              <a14:hiddenFill xmlns="" xmlns:a14="http://schemas.microsoft.com/office/drawing/2010/main">
                 <a:solidFill>
                   <a:srgbClr val="FFFFFF"/>
                 </a:solidFill>
               </a14:hiddenFill>
             </a:ext>
             <a:ext uri="{91240B29-F687-4f45-9708-019B960494DF}">
-              <a14:hiddenLine xmlns:a14="http://schemas.microsoft.com/office/drawing/2010/main" xmlns="" w="9525">
+              <a14:hiddenLine xmlns="" xmlns:a14="http://schemas.microsoft.com/office/drawing/2010/main" w="9525">
                 <a:solidFill>
                   <a:srgbClr val="000000"/>
                 </a:solidFill>
@@ -15888,14 +15891,14 @@
           </a:ln>
           <a:extLst>
             <a:ext uri="{909E8E84-426E-40dd-AFC4-6F175D3DCCD1}">
-              <a14:hiddenFill xmlns:a14="http://schemas.microsoft.com/office/drawing/2010/main" xmlns="">
+              <a14:hiddenFill xmlns="" xmlns:a14="http://schemas.microsoft.com/office/drawing/2010/main">
                 <a:solidFill>
                   <a:srgbClr val="FFFFFF"/>
                 </a:solidFill>
               </a14:hiddenFill>
             </a:ext>
             <a:ext uri="{91240B29-F687-4f45-9708-019B960494DF}">
-              <a14:hiddenLine xmlns:a14="http://schemas.microsoft.com/office/drawing/2010/main" xmlns="" w="12700" cap="sq">
+              <a14:hiddenLine xmlns="" xmlns:a14="http://schemas.microsoft.com/office/drawing/2010/main" w="12700" cap="sq">
                 <a:solidFill>
                   <a:srgbClr val="000000"/>
                 </a:solidFill>
@@ -16067,7 +16070,7 @@
           </a:ln>
           <a:extLst>
             <a:ext uri="{91240B29-F687-4f45-9708-019B960494DF}">
-              <a14:hiddenLine xmlns:a14="http://schemas.microsoft.com/office/drawing/2010/main" xmlns="" w="12700" cap="sq">
+              <a14:hiddenLine xmlns="" xmlns:a14="http://schemas.microsoft.com/office/drawing/2010/main" w="12700" cap="sq">
                 <a:solidFill>
                   <a:srgbClr val="000000"/>
                 </a:solidFill>
@@ -16429,14 +16432,14 @@
           <a:ln/>
           <a:extLst>
             <a:ext uri="{909E8E84-426E-40dd-AFC4-6F175D3DCCD1}">
-              <a14:hiddenFill xmlns:a14="http://schemas.microsoft.com/office/drawing/2010/main" xmlns="">
+              <a14:hiddenFill xmlns="" xmlns:a14="http://schemas.microsoft.com/office/drawing/2010/main">
                 <a:solidFill>
                   <a:srgbClr val="FFFFFF"/>
                 </a:solidFill>
               </a14:hiddenFill>
             </a:ext>
             <a:ext uri="{91240B29-F687-4f45-9708-019B960494DF}">
-              <a14:hiddenLine xmlns:a14="http://schemas.microsoft.com/office/drawing/2010/main" xmlns="" w="9525">
+              <a14:hiddenLine xmlns="" xmlns:a14="http://schemas.microsoft.com/office/drawing/2010/main" w="9525">
                 <a:solidFill>
                   <a:srgbClr val="000000"/>
                 </a:solidFill>
@@ -16591,7 +16594,7 @@
           </a:ln>
           <a:extLst>
             <a:ext uri="{91240B29-F687-4f45-9708-019B960494DF}">
-              <a14:hiddenLine xmlns:a14="http://schemas.microsoft.com/office/drawing/2010/main" xmlns="" w="12700" cap="sq">
+              <a14:hiddenLine xmlns="" xmlns:a14="http://schemas.microsoft.com/office/drawing/2010/main" w="12700" cap="sq">
                 <a:solidFill>
                   <a:srgbClr val="000000"/>
                 </a:solidFill>
@@ -16769,7 +16772,7 @@
             </a:ln>
             <a:extLst>
               <a:ext uri="{91240B29-F687-4f45-9708-019B960494DF}">
-                <a14:hiddenLine xmlns:a14="http://schemas.microsoft.com/office/drawing/2010/main" xmlns="" w="12700" cap="sq">
+                <a14:hiddenLine xmlns="" xmlns:a14="http://schemas.microsoft.com/office/drawing/2010/main" w="12700" cap="sq">
                   <a:solidFill>
                     <a:srgbClr val="000000"/>
                   </a:solidFill>
@@ -16929,14 +16932,14 @@
             </a:ln>
             <a:extLst>
               <a:ext uri="{909E8E84-426E-40dd-AFC4-6F175D3DCCD1}">
-                <a14:hiddenFill xmlns:a14="http://schemas.microsoft.com/office/drawing/2010/main" xmlns="">
+                <a14:hiddenFill xmlns="" xmlns:a14="http://schemas.microsoft.com/office/drawing/2010/main">
                   <a:solidFill>
                     <a:srgbClr val="FFFFFF"/>
                   </a:solidFill>
                 </a14:hiddenFill>
               </a:ext>
               <a:ext uri="{91240B29-F687-4f45-9708-019B960494DF}">
-                <a14:hiddenLine xmlns:a14="http://schemas.microsoft.com/office/drawing/2010/main" xmlns="" w="12700" cap="sq">
+                <a14:hiddenLine xmlns="" xmlns:a14="http://schemas.microsoft.com/office/drawing/2010/main" w="12700" cap="sq">
                   <a:solidFill>
                     <a:srgbClr val="000000"/>
                   </a:solidFill>
@@ -17109,7 +17112,7 @@
             </a:ln>
             <a:extLst>
               <a:ext uri="{91240B29-F687-4f45-9708-019B960494DF}">
-                <a14:hiddenLine xmlns:a14="http://schemas.microsoft.com/office/drawing/2010/main" xmlns="" w="12700" cap="sq">
+                <a14:hiddenLine xmlns="" xmlns:a14="http://schemas.microsoft.com/office/drawing/2010/main" w="12700" cap="sq">
                   <a:solidFill>
                     <a:srgbClr val="000000"/>
                   </a:solidFill>
@@ -17269,14 +17272,14 @@
             </a:ln>
             <a:extLst>
               <a:ext uri="{909E8E84-426E-40dd-AFC4-6F175D3DCCD1}">
-                <a14:hiddenFill xmlns:a14="http://schemas.microsoft.com/office/drawing/2010/main" xmlns="">
+                <a14:hiddenFill xmlns="" xmlns:a14="http://schemas.microsoft.com/office/drawing/2010/main">
                   <a:solidFill>
                     <a:srgbClr val="FFFFFF"/>
                   </a:solidFill>
                 </a14:hiddenFill>
               </a:ext>
               <a:ext uri="{91240B29-F687-4f45-9708-019B960494DF}">
-                <a14:hiddenLine xmlns:a14="http://schemas.microsoft.com/office/drawing/2010/main" xmlns="" w="12700" cap="sq">
+                <a14:hiddenLine xmlns="" xmlns:a14="http://schemas.microsoft.com/office/drawing/2010/main" w="12700" cap="sq">
                   <a:solidFill>
                     <a:srgbClr val="000000"/>
                   </a:solidFill>
@@ -17449,7 +17452,7 @@
             </a:ln>
             <a:extLst>
               <a:ext uri="{91240B29-F687-4f45-9708-019B960494DF}">
-                <a14:hiddenLine xmlns:a14="http://schemas.microsoft.com/office/drawing/2010/main" xmlns="" w="12700" cap="sq">
+                <a14:hiddenLine xmlns="" xmlns:a14="http://schemas.microsoft.com/office/drawing/2010/main" w="12700" cap="sq">
                   <a:solidFill>
                     <a:srgbClr val="000000"/>
                   </a:solidFill>
@@ -17609,14 +17612,14 @@
             </a:ln>
             <a:extLst>
               <a:ext uri="{909E8E84-426E-40dd-AFC4-6F175D3DCCD1}">
-                <a14:hiddenFill xmlns:a14="http://schemas.microsoft.com/office/drawing/2010/main" xmlns="">
+                <a14:hiddenFill xmlns="" xmlns:a14="http://schemas.microsoft.com/office/drawing/2010/main">
                   <a:solidFill>
                     <a:srgbClr val="FFFFFF"/>
                   </a:solidFill>
                 </a14:hiddenFill>
               </a:ext>
               <a:ext uri="{91240B29-F687-4f45-9708-019B960494DF}">
-                <a14:hiddenLine xmlns:a14="http://schemas.microsoft.com/office/drawing/2010/main" xmlns="" w="12700" cap="sq">
+                <a14:hiddenLine xmlns="" xmlns:a14="http://schemas.microsoft.com/office/drawing/2010/main" w="12700" cap="sq">
                   <a:solidFill>
                     <a:srgbClr val="000000"/>
                   </a:solidFill>
@@ -17787,14 +17790,14 @@
             </a:ln>
             <a:extLst>
               <a:ext uri="{909E8E84-426E-40dd-AFC4-6F175D3DCCD1}">
-                <a14:hiddenFill xmlns:a14="http://schemas.microsoft.com/office/drawing/2010/main" xmlns="">
+                <a14:hiddenFill xmlns="" xmlns:a14="http://schemas.microsoft.com/office/drawing/2010/main">
                   <a:solidFill>
                     <a:srgbClr val="FFFFFF"/>
                   </a:solidFill>
                 </a14:hiddenFill>
               </a:ext>
               <a:ext uri="{91240B29-F687-4f45-9708-019B960494DF}">
-                <a14:hiddenLine xmlns:a14="http://schemas.microsoft.com/office/drawing/2010/main" xmlns="" w="12700" cap="sq">
+                <a14:hiddenLine xmlns="" xmlns:a14="http://schemas.microsoft.com/office/drawing/2010/main" w="12700" cap="sq">
                   <a:solidFill>
                     <a:srgbClr val="000000"/>
                   </a:solidFill>
@@ -17949,7 +17952,7 @@
             </a:ln>
             <a:extLst>
               <a:ext uri="{91240B29-F687-4f45-9708-019B960494DF}">
-                <a14:hiddenLine xmlns:a14="http://schemas.microsoft.com/office/drawing/2010/main" xmlns="" w="12700" cap="sq">
+                <a14:hiddenLine xmlns="" xmlns:a14="http://schemas.microsoft.com/office/drawing/2010/main" w="12700" cap="sq">
                   <a:solidFill>
                     <a:srgbClr val="000000"/>
                   </a:solidFill>
@@ -18142,7 +18145,7 @@
           </a:ln>
           <a:extLst>
             <a:ext uri="{909E8E84-426E-40dd-AFC4-6F175D3DCCD1}">
-              <a14:hiddenFill xmlns:a14="http://schemas.microsoft.com/office/drawing/2010/main" xmlns="">
+              <a14:hiddenFill xmlns="" xmlns:a14="http://schemas.microsoft.com/office/drawing/2010/main">
                 <a:solidFill>
                   <a:srgbClr val="FFFFFF"/>
                 </a:solidFill>
@@ -18206,14 +18209,14 @@
           </a:ln>
           <a:extLst>
             <a:ext uri="{909E8E84-426E-40dd-AFC4-6F175D3DCCD1}">
-              <a14:hiddenFill xmlns:a14="http://schemas.microsoft.com/office/drawing/2010/main" xmlns="">
+              <a14:hiddenFill xmlns="" xmlns:a14="http://schemas.microsoft.com/office/drawing/2010/main">
                 <a:solidFill>
                   <a:srgbClr val="FFFFFF"/>
                 </a:solidFill>
               </a14:hiddenFill>
             </a:ext>
             <a:ext uri="{91240B29-F687-4f45-9708-019B960494DF}">
-              <a14:hiddenLine xmlns:a14="http://schemas.microsoft.com/office/drawing/2010/main" xmlns="" w="12700" cap="sq">
+              <a14:hiddenLine xmlns="" xmlns:a14="http://schemas.microsoft.com/office/drawing/2010/main" w="12700" cap="sq">
                 <a:solidFill>
                   <a:srgbClr val="000000"/>
                 </a:solidFill>
@@ -18682,14 +18685,14 @@
           <a:ln/>
           <a:extLst>
             <a:ext uri="{909E8E84-426E-40dd-AFC4-6F175D3DCCD1}">
-              <a14:hiddenFill xmlns:a14="http://schemas.microsoft.com/office/drawing/2010/main" xmlns="">
+              <a14:hiddenFill xmlns="" xmlns:a14="http://schemas.microsoft.com/office/drawing/2010/main">
                 <a:solidFill>
                   <a:srgbClr val="FFFFFF"/>
                 </a:solidFill>
               </a14:hiddenFill>
             </a:ext>
             <a:ext uri="{91240B29-F687-4f45-9708-019B960494DF}">
-              <a14:hiddenLine xmlns:a14="http://schemas.microsoft.com/office/drawing/2010/main" xmlns="" w="9525">
+              <a14:hiddenLine xmlns="" xmlns:a14="http://schemas.microsoft.com/office/drawing/2010/main" w="9525">
                 <a:solidFill>
                   <a:srgbClr val="000000"/>
                 </a:solidFill>
@@ -18842,14 +18845,14 @@
           </a:ln>
           <a:extLst>
             <a:ext uri="{909E8E84-426E-40dd-AFC4-6F175D3DCCD1}">
-              <a14:hiddenFill xmlns:a14="http://schemas.microsoft.com/office/drawing/2010/main" xmlns="">
+              <a14:hiddenFill xmlns="" xmlns:a14="http://schemas.microsoft.com/office/drawing/2010/main">
                 <a:solidFill>
                   <a:srgbClr val="FFFFFF"/>
                 </a:solidFill>
               </a14:hiddenFill>
             </a:ext>
             <a:ext uri="{91240B29-F687-4f45-9708-019B960494DF}">
-              <a14:hiddenLine xmlns:a14="http://schemas.microsoft.com/office/drawing/2010/main" xmlns="" w="12700" cap="sq">
+              <a14:hiddenLine xmlns="" xmlns:a14="http://schemas.microsoft.com/office/drawing/2010/main" w="12700" cap="sq">
                 <a:solidFill>
                   <a:srgbClr val="000000"/>
                 </a:solidFill>
@@ -19004,7 +19007,7 @@
           </a:ln>
           <a:extLst>
             <a:ext uri="{91240B29-F687-4f45-9708-019B960494DF}">
-              <a14:hiddenLine xmlns:a14="http://schemas.microsoft.com/office/drawing/2010/main" xmlns="" w="12700" cap="sq">
+              <a14:hiddenLine xmlns="" xmlns:a14="http://schemas.microsoft.com/office/drawing/2010/main" w="12700" cap="sq">
                 <a:solidFill>
                   <a:srgbClr val="000000"/>
                 </a:solidFill>
@@ -19203,7 +19206,7 @@
           </a:ln>
           <a:extLst>
             <a:ext uri="{91240B29-F687-4f45-9708-019B960494DF}">
-              <a14:hiddenLine xmlns:a14="http://schemas.microsoft.com/office/drawing/2010/main" xmlns="" w="12700" cap="sq">
+              <a14:hiddenLine xmlns="" xmlns:a14="http://schemas.microsoft.com/office/drawing/2010/main" w="12700" cap="sq">
                 <a:solidFill>
                   <a:srgbClr val="000000"/>
                 </a:solidFill>
@@ -19381,7 +19384,7 @@
             </a:ln>
             <a:extLst>
               <a:ext uri="{91240B29-F687-4f45-9708-019B960494DF}">
-                <a14:hiddenLine xmlns:a14="http://schemas.microsoft.com/office/drawing/2010/main" xmlns="" w="12700" cap="sq">
+                <a14:hiddenLine xmlns="" xmlns:a14="http://schemas.microsoft.com/office/drawing/2010/main" w="12700" cap="sq">
                   <a:solidFill>
                     <a:srgbClr val="000000"/>
                   </a:solidFill>
@@ -19541,14 +19544,14 @@
             </a:ln>
             <a:extLst>
               <a:ext uri="{909E8E84-426E-40dd-AFC4-6F175D3DCCD1}">
-                <a14:hiddenFill xmlns:a14="http://schemas.microsoft.com/office/drawing/2010/main" xmlns="">
+                <a14:hiddenFill xmlns="" xmlns:a14="http://schemas.microsoft.com/office/drawing/2010/main">
                   <a:solidFill>
                     <a:srgbClr val="FFFFFF"/>
                   </a:solidFill>
                 </a14:hiddenFill>
               </a:ext>
               <a:ext uri="{91240B29-F687-4f45-9708-019B960494DF}">
-                <a14:hiddenLine xmlns:a14="http://schemas.microsoft.com/office/drawing/2010/main" xmlns="" w="12700" cap="sq">
+                <a14:hiddenLine xmlns="" xmlns:a14="http://schemas.microsoft.com/office/drawing/2010/main" w="12700" cap="sq">
                   <a:solidFill>
                     <a:srgbClr val="000000"/>
                   </a:solidFill>
@@ -19721,7 +19724,7 @@
             </a:ln>
             <a:extLst>
               <a:ext uri="{91240B29-F687-4f45-9708-019B960494DF}">
-                <a14:hiddenLine xmlns:a14="http://schemas.microsoft.com/office/drawing/2010/main" xmlns="" w="12700" cap="sq">
+                <a14:hiddenLine xmlns="" xmlns:a14="http://schemas.microsoft.com/office/drawing/2010/main" w="12700" cap="sq">
                   <a:solidFill>
                     <a:srgbClr val="000000"/>
                   </a:solidFill>
@@ -19881,14 +19884,14 @@
             </a:ln>
             <a:extLst>
               <a:ext uri="{909E8E84-426E-40dd-AFC4-6F175D3DCCD1}">
-                <a14:hiddenFill xmlns:a14="http://schemas.microsoft.com/office/drawing/2010/main" xmlns="">
+                <a14:hiddenFill xmlns="" xmlns:a14="http://schemas.microsoft.com/office/drawing/2010/main">
                   <a:solidFill>
                     <a:srgbClr val="FFFFFF"/>
                   </a:solidFill>
                 </a14:hiddenFill>
               </a:ext>
               <a:ext uri="{91240B29-F687-4f45-9708-019B960494DF}">
-                <a14:hiddenLine xmlns:a14="http://schemas.microsoft.com/office/drawing/2010/main" xmlns="" w="12700" cap="sq">
+                <a14:hiddenLine xmlns="" xmlns:a14="http://schemas.microsoft.com/office/drawing/2010/main" w="12700" cap="sq">
                   <a:solidFill>
                     <a:srgbClr val="000000"/>
                   </a:solidFill>
@@ -20061,7 +20064,7 @@
             </a:ln>
             <a:extLst>
               <a:ext uri="{91240B29-F687-4f45-9708-019B960494DF}">
-                <a14:hiddenLine xmlns:a14="http://schemas.microsoft.com/office/drawing/2010/main" xmlns="" w="12700" cap="sq">
+                <a14:hiddenLine xmlns="" xmlns:a14="http://schemas.microsoft.com/office/drawing/2010/main" w="12700" cap="sq">
                   <a:solidFill>
                     <a:srgbClr val="000000"/>
                   </a:solidFill>
@@ -20221,14 +20224,14 @@
             </a:ln>
             <a:extLst>
               <a:ext uri="{909E8E84-426E-40dd-AFC4-6F175D3DCCD1}">
-                <a14:hiddenFill xmlns:a14="http://schemas.microsoft.com/office/drawing/2010/main" xmlns="">
+                <a14:hiddenFill xmlns="" xmlns:a14="http://schemas.microsoft.com/office/drawing/2010/main">
                   <a:solidFill>
                     <a:srgbClr val="FFFFFF"/>
                   </a:solidFill>
                 </a14:hiddenFill>
               </a:ext>
               <a:ext uri="{91240B29-F687-4f45-9708-019B960494DF}">
-                <a14:hiddenLine xmlns:a14="http://schemas.microsoft.com/office/drawing/2010/main" xmlns="" w="12700" cap="sq">
+                <a14:hiddenLine xmlns="" xmlns:a14="http://schemas.microsoft.com/office/drawing/2010/main" w="12700" cap="sq">
                   <a:solidFill>
                     <a:srgbClr val="000000"/>
                   </a:solidFill>
@@ -20383,14 +20386,14 @@
           </a:ln>
           <a:extLst>
             <a:ext uri="{909E8E84-426E-40dd-AFC4-6F175D3DCCD1}">
-              <a14:hiddenFill xmlns:a14="http://schemas.microsoft.com/office/drawing/2010/main" xmlns="">
+              <a14:hiddenFill xmlns="" xmlns:a14="http://schemas.microsoft.com/office/drawing/2010/main">
                 <a:solidFill>
                   <a:srgbClr val="FFFFFF"/>
                 </a:solidFill>
               </a14:hiddenFill>
             </a:ext>
             <a:ext uri="{91240B29-F687-4f45-9708-019B960494DF}">
-              <a14:hiddenLine xmlns:a14="http://schemas.microsoft.com/office/drawing/2010/main" xmlns="" w="12700" cap="sq">
+              <a14:hiddenLine xmlns="" xmlns:a14="http://schemas.microsoft.com/office/drawing/2010/main" w="12700" cap="sq">
                 <a:solidFill>
                   <a:srgbClr val="000000"/>
                 </a:solidFill>
@@ -20554,7 +20557,7 @@
           </a:ln>
           <a:extLst>
             <a:ext uri="{909E8E84-426E-40dd-AFC4-6F175D3DCCD1}">
-              <a14:hiddenFill xmlns:a14="http://schemas.microsoft.com/office/drawing/2010/main" xmlns="">
+              <a14:hiddenFill xmlns="" xmlns:a14="http://schemas.microsoft.com/office/drawing/2010/main">
                 <a:solidFill>
                   <a:srgbClr val="FFFFFF"/>
                 </a:solidFill>
@@ -20941,14 +20944,14 @@
           <a:ln/>
           <a:extLst>
             <a:ext uri="{909E8E84-426E-40dd-AFC4-6F175D3DCCD1}">
-              <a14:hiddenFill xmlns:a14="http://schemas.microsoft.com/office/drawing/2010/main" xmlns="">
+              <a14:hiddenFill xmlns="" xmlns:a14="http://schemas.microsoft.com/office/drawing/2010/main">
                 <a:solidFill>
                   <a:srgbClr val="FFFFFF"/>
                 </a:solidFill>
               </a14:hiddenFill>
             </a:ext>
             <a:ext uri="{91240B29-F687-4f45-9708-019B960494DF}">
-              <a14:hiddenLine xmlns:a14="http://schemas.microsoft.com/office/drawing/2010/main" xmlns="" w="9525">
+              <a14:hiddenLine xmlns="" xmlns:a14="http://schemas.microsoft.com/office/drawing/2010/main" w="9525">
                 <a:solidFill>
                   <a:srgbClr val="000000"/>
                 </a:solidFill>
@@ -21101,14 +21104,14 @@
           </a:ln>
           <a:extLst>
             <a:ext uri="{909E8E84-426E-40dd-AFC4-6F175D3DCCD1}">
-              <a14:hiddenFill xmlns:a14="http://schemas.microsoft.com/office/drawing/2010/main" xmlns="">
+              <a14:hiddenFill xmlns="" xmlns:a14="http://schemas.microsoft.com/office/drawing/2010/main">
                 <a:solidFill>
                   <a:srgbClr val="FFFFFF"/>
                 </a:solidFill>
               </a14:hiddenFill>
             </a:ext>
             <a:ext uri="{91240B29-F687-4f45-9708-019B960494DF}">
-              <a14:hiddenLine xmlns:a14="http://schemas.microsoft.com/office/drawing/2010/main" xmlns="" w="12700" cap="sq">
+              <a14:hiddenLine xmlns="" xmlns:a14="http://schemas.microsoft.com/office/drawing/2010/main" w="12700" cap="sq">
                 <a:solidFill>
                   <a:srgbClr val="000000"/>
                 </a:solidFill>
@@ -21263,7 +21266,7 @@
           </a:ln>
           <a:extLst>
             <a:ext uri="{91240B29-F687-4f45-9708-019B960494DF}">
-              <a14:hiddenLine xmlns:a14="http://schemas.microsoft.com/office/drawing/2010/main" xmlns="" w="12700" cap="sq">
+              <a14:hiddenLine xmlns="" xmlns:a14="http://schemas.microsoft.com/office/drawing/2010/main" w="12700" cap="sq">
                 <a:solidFill>
                   <a:srgbClr val="000000"/>
                 </a:solidFill>
@@ -21485,14 +21488,14 @@
           </a:ln>
           <a:extLst>
             <a:ext uri="{909E8E84-426E-40dd-AFC4-6F175D3DCCD1}">
-              <a14:hiddenFill xmlns:a14="http://schemas.microsoft.com/office/drawing/2010/main" xmlns="">
+              <a14:hiddenFill xmlns="" xmlns:a14="http://schemas.microsoft.com/office/drawing/2010/main">
                 <a:solidFill>
                   <a:srgbClr val="FFFFFF"/>
                 </a:solidFill>
               </a14:hiddenFill>
             </a:ext>
             <a:ext uri="{91240B29-F687-4f45-9708-019B960494DF}">
-              <a14:hiddenLine xmlns:a14="http://schemas.microsoft.com/office/drawing/2010/main" xmlns="" w="12700" cap="sq">
+              <a14:hiddenLine xmlns="" xmlns:a14="http://schemas.microsoft.com/office/drawing/2010/main" w="12700" cap="sq">
                 <a:solidFill>
                   <a:srgbClr val="000000"/>
                 </a:solidFill>
@@ -21657,7 +21660,7 @@
           </a:ln>
           <a:extLst>
             <a:ext uri="{91240B29-F687-4f45-9708-019B960494DF}">
-              <a14:hiddenLine xmlns:a14="http://schemas.microsoft.com/office/drawing/2010/main" xmlns="" w="12700" cap="sq">
+              <a14:hiddenLine xmlns="" xmlns:a14="http://schemas.microsoft.com/office/drawing/2010/main" w="12700" cap="sq">
                 <a:solidFill>
                   <a:srgbClr val="000000"/>
                 </a:solidFill>
@@ -21823,7 +21826,7 @@
           </a:ln>
           <a:extLst>
             <a:ext uri="{909E8E84-426E-40dd-AFC4-6F175D3DCCD1}">
-              <a14:hiddenFill xmlns:a14="http://schemas.microsoft.com/office/drawing/2010/main" xmlns="">
+              <a14:hiddenFill xmlns="" xmlns:a14="http://schemas.microsoft.com/office/drawing/2010/main">
                 <a:solidFill>
                   <a:srgbClr val="FFFFFF"/>
                 </a:solidFill>
@@ -21919,14 +21922,14 @@
           <a:ln/>
           <a:extLst>
             <a:ext uri="{909E8E84-426E-40dd-AFC4-6F175D3DCCD1}">
-              <a14:hiddenFill xmlns:a14="http://schemas.microsoft.com/office/drawing/2010/main" xmlns="">
+              <a14:hiddenFill xmlns="" xmlns:a14="http://schemas.microsoft.com/office/drawing/2010/main">
                 <a:solidFill>
                   <a:srgbClr val="FFFFFF"/>
                 </a:solidFill>
               </a14:hiddenFill>
             </a:ext>
             <a:ext uri="{91240B29-F687-4f45-9708-019B960494DF}">
-              <a14:hiddenLine xmlns:a14="http://schemas.microsoft.com/office/drawing/2010/main" xmlns="" w="9525">
+              <a14:hiddenLine xmlns="" xmlns:a14="http://schemas.microsoft.com/office/drawing/2010/main" w="9525">
                 <a:solidFill>
                   <a:srgbClr val="000000"/>
                 </a:solidFill>
@@ -22194,14 +22197,14 @@
           <a:ln/>
           <a:extLst>
             <a:ext uri="{909E8E84-426E-40dd-AFC4-6F175D3DCCD1}">
-              <a14:hiddenFill xmlns:a14="http://schemas.microsoft.com/office/drawing/2010/main" xmlns="">
+              <a14:hiddenFill xmlns="" xmlns:a14="http://schemas.microsoft.com/office/drawing/2010/main">
                 <a:solidFill>
                   <a:srgbClr val="FFFFFF"/>
                 </a:solidFill>
               </a14:hiddenFill>
             </a:ext>
             <a:ext uri="{91240B29-F687-4f45-9708-019B960494DF}">
-              <a14:hiddenLine xmlns:a14="http://schemas.microsoft.com/office/drawing/2010/main" xmlns="" w="9525">
+              <a14:hiddenLine xmlns="" xmlns:a14="http://schemas.microsoft.com/office/drawing/2010/main" w="9525">
                 <a:solidFill>
                   <a:srgbClr val="000000"/>
                 </a:solidFill>
@@ -22354,14 +22357,14 @@
           </a:ln>
           <a:extLst>
             <a:ext uri="{909E8E84-426E-40dd-AFC4-6F175D3DCCD1}">
-              <a14:hiddenFill xmlns:a14="http://schemas.microsoft.com/office/drawing/2010/main" xmlns="">
+              <a14:hiddenFill xmlns="" xmlns:a14="http://schemas.microsoft.com/office/drawing/2010/main">
                 <a:solidFill>
                   <a:srgbClr val="FFFFFF"/>
                 </a:solidFill>
               </a14:hiddenFill>
             </a:ext>
             <a:ext uri="{91240B29-F687-4f45-9708-019B960494DF}">
-              <a14:hiddenLine xmlns:a14="http://schemas.microsoft.com/office/drawing/2010/main" xmlns="" w="9525">
+              <a14:hiddenLine xmlns="" xmlns:a14="http://schemas.microsoft.com/office/drawing/2010/main" w="9525">
                 <a:solidFill>
                   <a:srgbClr val="000000"/>
                 </a:solidFill>
@@ -22792,14 +22795,14 @@
           <a:ln/>
           <a:extLst>
             <a:ext uri="{909E8E84-426E-40dd-AFC4-6F175D3DCCD1}">
-              <a14:hiddenFill xmlns:a14="http://schemas.microsoft.com/office/drawing/2010/main" xmlns="">
+              <a14:hiddenFill xmlns="" xmlns:a14="http://schemas.microsoft.com/office/drawing/2010/main">
                 <a:solidFill>
                   <a:srgbClr val="FFFFFF"/>
                 </a:solidFill>
               </a14:hiddenFill>
             </a:ext>
             <a:ext uri="{91240B29-F687-4f45-9708-019B960494DF}">
-              <a14:hiddenLine xmlns:a14="http://schemas.microsoft.com/office/drawing/2010/main" xmlns="" w="9525">
+              <a14:hiddenLine xmlns="" xmlns:a14="http://schemas.microsoft.com/office/drawing/2010/main" w="9525">
                 <a:solidFill>
                   <a:srgbClr val="000000"/>
                 </a:solidFill>
@@ -22952,14 +22955,14 @@
           </a:ln>
           <a:extLst>
             <a:ext uri="{909E8E84-426E-40dd-AFC4-6F175D3DCCD1}">
-              <a14:hiddenFill xmlns:a14="http://schemas.microsoft.com/office/drawing/2010/main" xmlns="">
+              <a14:hiddenFill xmlns="" xmlns:a14="http://schemas.microsoft.com/office/drawing/2010/main">
                 <a:solidFill>
                   <a:srgbClr val="FFFFFF"/>
                 </a:solidFill>
               </a14:hiddenFill>
             </a:ext>
             <a:ext uri="{91240B29-F687-4f45-9708-019B960494DF}">
-              <a14:hiddenLine xmlns:a14="http://schemas.microsoft.com/office/drawing/2010/main" xmlns="" w="12700" cap="sq">
+              <a14:hiddenLine xmlns="" xmlns:a14="http://schemas.microsoft.com/office/drawing/2010/main" w="12700" cap="sq">
                 <a:solidFill>
                   <a:srgbClr val="000000"/>
                 </a:solidFill>
@@ -23122,7 +23125,7 @@
           </a:ln>
           <a:extLst>
             <a:ext uri="{91240B29-F687-4f45-9708-019B960494DF}">
-              <a14:hiddenLine xmlns:a14="http://schemas.microsoft.com/office/drawing/2010/main" xmlns="" w="12700" cap="sq">
+              <a14:hiddenLine xmlns="" xmlns:a14="http://schemas.microsoft.com/office/drawing/2010/main" w="12700" cap="sq">
                 <a:solidFill>
                   <a:srgbClr val="000000"/>
                 </a:solidFill>
@@ -23372,7 +23375,7 @@
           </a:ln>
           <a:extLst>
             <a:ext uri="{909E8E84-426E-40dd-AFC4-6F175D3DCCD1}">
-              <a14:hiddenFill xmlns:a14="http://schemas.microsoft.com/office/drawing/2010/main" xmlns="">
+              <a14:hiddenFill xmlns="" xmlns:a14="http://schemas.microsoft.com/office/drawing/2010/main">
                 <a:solidFill>
                   <a:srgbClr val="FFFFFF"/>
                 </a:solidFill>
@@ -23681,14 +23684,14 @@
           <a:ln/>
           <a:extLst>
             <a:ext uri="{909E8E84-426E-40dd-AFC4-6F175D3DCCD1}">
-              <a14:hiddenFill xmlns:a14="http://schemas.microsoft.com/office/drawing/2010/main" xmlns="">
+              <a14:hiddenFill xmlns="" xmlns:a14="http://schemas.microsoft.com/office/drawing/2010/main">
                 <a:solidFill>
                   <a:srgbClr val="FFFFFF"/>
                 </a:solidFill>
               </a14:hiddenFill>
             </a:ext>
             <a:ext uri="{91240B29-F687-4f45-9708-019B960494DF}">
-              <a14:hiddenLine xmlns:a14="http://schemas.microsoft.com/office/drawing/2010/main" xmlns="" w="9525">
+              <a14:hiddenLine xmlns="" xmlns:a14="http://schemas.microsoft.com/office/drawing/2010/main" w="9525">
                 <a:solidFill>
                   <a:srgbClr val="000000"/>
                 </a:solidFill>
@@ -23841,14 +23844,14 @@
           </a:ln>
           <a:extLst>
             <a:ext uri="{909E8E84-426E-40dd-AFC4-6F175D3DCCD1}">
-              <a14:hiddenFill xmlns:a14="http://schemas.microsoft.com/office/drawing/2010/main" xmlns="">
+              <a14:hiddenFill xmlns="" xmlns:a14="http://schemas.microsoft.com/office/drawing/2010/main">
                 <a:solidFill>
                   <a:srgbClr val="FFFFFF"/>
                 </a:solidFill>
               </a14:hiddenFill>
             </a:ext>
             <a:ext uri="{91240B29-F687-4f45-9708-019B960494DF}">
-              <a14:hiddenLine xmlns:a14="http://schemas.microsoft.com/office/drawing/2010/main" xmlns="" w="12700" cap="sq">
+              <a14:hiddenLine xmlns="" xmlns:a14="http://schemas.microsoft.com/office/drawing/2010/main" w="12700" cap="sq">
                 <a:solidFill>
                   <a:srgbClr val="000000"/>
                 </a:solidFill>
@@ -24011,7 +24014,7 @@
           </a:ln>
           <a:extLst>
             <a:ext uri="{91240B29-F687-4f45-9708-019B960494DF}">
-              <a14:hiddenLine xmlns:a14="http://schemas.microsoft.com/office/drawing/2010/main" xmlns="" w="12700" cap="sq">
+              <a14:hiddenLine xmlns="" xmlns:a14="http://schemas.microsoft.com/office/drawing/2010/main" w="12700" cap="sq">
                 <a:solidFill>
                   <a:srgbClr val="000000"/>
                 </a:solidFill>
@@ -24275,14 +24278,14 @@
           </a:ln>
           <a:extLst>
             <a:ext uri="{909E8E84-426E-40dd-AFC4-6F175D3DCCD1}">
-              <a14:hiddenFill xmlns:a14="http://schemas.microsoft.com/office/drawing/2010/main" xmlns="">
+              <a14:hiddenFill xmlns="" xmlns:a14="http://schemas.microsoft.com/office/drawing/2010/main">
                 <a:solidFill>
                   <a:srgbClr val="FFFFFF"/>
                 </a:solidFill>
               </a14:hiddenFill>
             </a:ext>
             <a:ext uri="{91240B29-F687-4f45-9708-019B960494DF}">
-              <a14:hiddenLine xmlns:a14="http://schemas.microsoft.com/office/drawing/2010/main" xmlns="" w="12700" cap="sq">
+              <a14:hiddenLine xmlns="" xmlns:a14="http://schemas.microsoft.com/office/drawing/2010/main" w="12700" cap="sq">
                 <a:solidFill>
                   <a:srgbClr val="000000"/>
                 </a:solidFill>
@@ -24437,7 +24440,7 @@
           </a:ln>
           <a:extLst>
             <a:ext uri="{91240B29-F687-4f45-9708-019B960494DF}">
-              <a14:hiddenLine xmlns:a14="http://schemas.microsoft.com/office/drawing/2010/main" xmlns="" w="12700" cap="sq">
+              <a14:hiddenLine xmlns="" xmlns:a14="http://schemas.microsoft.com/office/drawing/2010/main" w="12700" cap="sq">
                 <a:solidFill>
                   <a:srgbClr val="000000"/>
                 </a:solidFill>
@@ -24615,7 +24618,7 @@
         </p:nvSpPr>
         <p:spPr>
           <a:xfrm>
-            <a:off x="8908727" y="4980911"/>
+            <a:off x="9112699" y="5106235"/>
             <a:ext cx="2770909" cy="1090789"/>
           </a:xfrm>
           <a:prstGeom prst="wedgeRectCallout">
@@ -25180,14 +25183,14 @@
           <a:ln/>
           <a:extLst>
             <a:ext uri="{909E8E84-426E-40dd-AFC4-6F175D3DCCD1}">
-              <a14:hiddenFill xmlns:a14="http://schemas.microsoft.com/office/drawing/2010/main" xmlns="">
+              <a14:hiddenFill xmlns="" xmlns:a14="http://schemas.microsoft.com/office/drawing/2010/main">
                 <a:solidFill>
                   <a:srgbClr val="FFFFFF"/>
                 </a:solidFill>
               </a14:hiddenFill>
             </a:ext>
             <a:ext uri="{91240B29-F687-4f45-9708-019B960494DF}">
-              <a14:hiddenLine xmlns:a14="http://schemas.microsoft.com/office/drawing/2010/main" xmlns="" w="9525">
+              <a14:hiddenLine xmlns="" xmlns:a14="http://schemas.microsoft.com/office/drawing/2010/main" w="9525">
                 <a:solidFill>
                   <a:srgbClr val="000000"/>
                 </a:solidFill>
@@ -25340,14 +25343,14 @@
           </a:ln>
           <a:extLst>
             <a:ext uri="{909E8E84-426E-40dd-AFC4-6F175D3DCCD1}">
-              <a14:hiddenFill xmlns:a14="http://schemas.microsoft.com/office/drawing/2010/main" xmlns="">
+              <a14:hiddenFill xmlns="" xmlns:a14="http://schemas.microsoft.com/office/drawing/2010/main">
                 <a:solidFill>
                   <a:srgbClr val="FFFFFF"/>
                 </a:solidFill>
               </a14:hiddenFill>
             </a:ext>
             <a:ext uri="{91240B29-F687-4f45-9708-019B960494DF}">
-              <a14:hiddenLine xmlns:a14="http://schemas.microsoft.com/office/drawing/2010/main" xmlns="" w="12700" cap="sq">
+              <a14:hiddenLine xmlns="" xmlns:a14="http://schemas.microsoft.com/office/drawing/2010/main" w="12700" cap="sq">
                 <a:solidFill>
                   <a:srgbClr val="000000"/>
                 </a:solidFill>
@@ -25510,7 +25513,7 @@
           </a:ln>
           <a:extLst>
             <a:ext uri="{91240B29-F687-4f45-9708-019B960494DF}">
-              <a14:hiddenLine xmlns:a14="http://schemas.microsoft.com/office/drawing/2010/main" xmlns="" w="12700" cap="sq">
+              <a14:hiddenLine xmlns="" xmlns:a14="http://schemas.microsoft.com/office/drawing/2010/main" w="12700" cap="sq">
                 <a:solidFill>
                   <a:srgbClr val="000000"/>
                 </a:solidFill>
@@ -25759,14 +25762,14 @@
           </a:ln>
           <a:extLst>
             <a:ext uri="{909E8E84-426E-40dd-AFC4-6F175D3DCCD1}">
-              <a14:hiddenFill xmlns:a14="http://schemas.microsoft.com/office/drawing/2010/main" xmlns="">
+              <a14:hiddenFill xmlns="" xmlns:a14="http://schemas.microsoft.com/office/drawing/2010/main">
                 <a:solidFill>
                   <a:srgbClr val="FFFFFF"/>
                 </a:solidFill>
               </a14:hiddenFill>
             </a:ext>
             <a:ext uri="{91240B29-F687-4f45-9708-019B960494DF}">
-              <a14:hiddenLine xmlns:a14="http://schemas.microsoft.com/office/drawing/2010/main" xmlns="" w="12700" cap="sq">
+              <a14:hiddenLine xmlns="" xmlns:a14="http://schemas.microsoft.com/office/drawing/2010/main" w="12700" cap="sq">
                 <a:solidFill>
                   <a:srgbClr val="000000"/>
                 </a:solidFill>
@@ -25921,7 +25924,7 @@
           </a:ln>
           <a:extLst>
             <a:ext uri="{91240B29-F687-4f45-9708-019B960494DF}">
-              <a14:hiddenLine xmlns:a14="http://schemas.microsoft.com/office/drawing/2010/main" xmlns="" w="12700" cap="sq">
+              <a14:hiddenLine xmlns="" xmlns:a14="http://schemas.microsoft.com/office/drawing/2010/main" w="12700" cap="sq">
                 <a:solidFill>
                   <a:srgbClr val="000000"/>
                 </a:solidFill>
@@ -26415,14 +26418,14 @@
           <a:ln/>
           <a:extLst>
             <a:ext uri="{909E8E84-426E-40dd-AFC4-6F175D3DCCD1}">
-              <a14:hiddenFill xmlns:a14="http://schemas.microsoft.com/office/drawing/2010/main" xmlns="">
+              <a14:hiddenFill xmlns="" xmlns:a14="http://schemas.microsoft.com/office/drawing/2010/main">
                 <a:solidFill>
                   <a:srgbClr val="FFFFFF"/>
                 </a:solidFill>
               </a14:hiddenFill>
             </a:ext>
             <a:ext uri="{91240B29-F687-4f45-9708-019B960494DF}">
-              <a14:hiddenLine xmlns:a14="http://schemas.microsoft.com/office/drawing/2010/main" xmlns="" w="9525">
+              <a14:hiddenLine xmlns="" xmlns:a14="http://schemas.microsoft.com/office/drawing/2010/main" w="9525">
                 <a:solidFill>
                   <a:srgbClr val="000000"/>
                 </a:solidFill>
@@ -26563,8 +26566,8 @@
         </p:nvSpPr>
         <p:spPr bwMode="auto">
           <a:xfrm>
-            <a:off x="756261" y="2132655"/>
-            <a:ext cx="8569325" cy="946150"/>
+            <a:off x="1109402" y="2132655"/>
+            <a:ext cx="9973196" cy="946150"/>
           </a:xfrm>
           <a:prstGeom prst="rect">
             <a:avLst/>
@@ -26575,14 +26578,433 @@
           </a:ln>
           <a:extLst>
             <a:ext uri="{909E8E84-426E-40dd-AFC4-6F175D3DCCD1}">
-              <a14:hiddenFill xmlns:a14="http://schemas.microsoft.com/office/drawing/2010/main" xmlns="">
+              <a14:hiddenFill xmlns="" xmlns:a14="http://schemas.microsoft.com/office/drawing/2010/main">
                 <a:solidFill>
                   <a:srgbClr val="FFFFFF"/>
                 </a:solidFill>
               </a14:hiddenFill>
             </a:ext>
             <a:ext uri="{91240B29-F687-4f45-9708-019B960494DF}">
-              <a14:hiddenLine xmlns:a14="http://schemas.microsoft.com/office/drawing/2010/main" xmlns="" w="12700" cap="sq">
+              <a14:hiddenLine xmlns="" xmlns:a14="http://schemas.microsoft.com/office/drawing/2010/main" w="12700" cap="sq">
+                <a:solidFill>
+                  <a:srgbClr val="000000"/>
+                </a:solidFill>
+                <a:miter lim="800000"/>
+                <a:headEnd/>
+                <a:tailEnd/>
+              </a14:hiddenLine>
+            </a:ext>
+          </a:extLst>
+        </p:spPr>
+        <p:txBody>
+          <a:bodyPr wrap="square" anchor="ctr">
+            <a:spAutoFit/>
+          </a:bodyPr>
+          <a:lstStyle>
+            <a:lvl1pPr>
+              <a:defRPr sz="2800">
+                <a:solidFill>
+                  <a:schemeClr val="tx1"/>
+                </a:solidFill>
+                <a:latin typeface="Tahoma" charset="0"/>
+                <a:ea typeface="ＭＳ Ｐゴシック" charset="0"/>
+                <a:cs typeface="ＭＳ Ｐゴシック" charset="0"/>
+              </a:defRPr>
+            </a:lvl1pPr>
+            <a:lvl2pPr marL="742950" indent="-285750">
+              <a:defRPr sz="2800">
+                <a:solidFill>
+                  <a:schemeClr val="tx1"/>
+                </a:solidFill>
+                <a:latin typeface="Tahoma" charset="0"/>
+                <a:ea typeface="ＭＳ Ｐゴシック" charset="0"/>
+              </a:defRPr>
+            </a:lvl2pPr>
+            <a:lvl3pPr marL="1143000" indent="-228600">
+              <a:defRPr sz="2800">
+                <a:solidFill>
+                  <a:schemeClr val="tx1"/>
+                </a:solidFill>
+                <a:latin typeface="Tahoma" charset="0"/>
+                <a:ea typeface="ＭＳ Ｐゴシック" charset="0"/>
+              </a:defRPr>
+            </a:lvl3pPr>
+            <a:lvl4pPr marL="1600200" indent="-228600">
+              <a:defRPr sz="2800">
+                <a:solidFill>
+                  <a:schemeClr val="tx1"/>
+                </a:solidFill>
+                <a:latin typeface="Tahoma" charset="0"/>
+                <a:ea typeface="ＭＳ Ｐゴシック" charset="0"/>
+              </a:defRPr>
+            </a:lvl4pPr>
+            <a:lvl5pPr marL="2057400" indent="-228600">
+              <a:defRPr sz="2800">
+                <a:solidFill>
+                  <a:schemeClr val="tx1"/>
+                </a:solidFill>
+                <a:latin typeface="Tahoma" charset="0"/>
+                <a:ea typeface="ＭＳ Ｐゴシック" charset="0"/>
+              </a:defRPr>
+            </a:lvl5pPr>
+            <a:lvl6pPr marL="2514600" indent="-228600" eaLnBrk="0" fontAlgn="base" hangingPunct="0">
+              <a:spcBef>
+                <a:spcPct val="0"/>
+              </a:spcBef>
+              <a:spcAft>
+                <a:spcPct val="0"/>
+              </a:spcAft>
+              <a:defRPr sz="2800">
+                <a:solidFill>
+                  <a:schemeClr val="tx1"/>
+                </a:solidFill>
+                <a:latin typeface="Tahoma" charset="0"/>
+                <a:ea typeface="ＭＳ Ｐゴシック" charset="0"/>
+              </a:defRPr>
+            </a:lvl6pPr>
+            <a:lvl7pPr marL="2971800" indent="-228600" eaLnBrk="0" fontAlgn="base" hangingPunct="0">
+              <a:spcBef>
+                <a:spcPct val="0"/>
+              </a:spcBef>
+              <a:spcAft>
+                <a:spcPct val="0"/>
+              </a:spcAft>
+              <a:defRPr sz="2800">
+                <a:solidFill>
+                  <a:schemeClr val="tx1"/>
+                </a:solidFill>
+                <a:latin typeface="Tahoma" charset="0"/>
+                <a:ea typeface="ＭＳ Ｐゴシック" charset="0"/>
+              </a:defRPr>
+            </a:lvl7pPr>
+            <a:lvl8pPr marL="3429000" indent="-228600" eaLnBrk="0" fontAlgn="base" hangingPunct="0">
+              <a:spcBef>
+                <a:spcPct val="0"/>
+              </a:spcBef>
+              <a:spcAft>
+                <a:spcPct val="0"/>
+              </a:spcAft>
+              <a:defRPr sz="2800">
+                <a:solidFill>
+                  <a:schemeClr val="tx1"/>
+                </a:solidFill>
+                <a:latin typeface="Tahoma" charset="0"/>
+                <a:ea typeface="ＭＳ Ｐゴシック" charset="0"/>
+              </a:defRPr>
+            </a:lvl8pPr>
+            <a:lvl9pPr marL="3886200" indent="-228600" eaLnBrk="0" fontAlgn="base" hangingPunct="0">
+              <a:spcBef>
+                <a:spcPct val="0"/>
+              </a:spcBef>
+              <a:spcAft>
+                <a:spcPct val="0"/>
+              </a:spcAft>
+              <a:defRPr sz="2800">
+                <a:solidFill>
+                  <a:schemeClr val="tx1"/>
+                </a:solidFill>
+                <a:latin typeface="Tahoma" charset="0"/>
+                <a:ea typeface="ＭＳ Ｐゴシック" charset="0"/>
+              </a:defRPr>
+            </a:lvl9pPr>
+          </a:lstStyle>
+          <a:p>
+            <a:r>
+              <a:rPr lang="en-US" dirty="0"/>
+              <a:t>Dually, the library function </a:t>
+            </a:r>
+            <a:r>
+              <a:rPr lang="en-US" u="sng" dirty="0"/>
+              <a:t>any</a:t>
+            </a:r>
+            <a:r>
+              <a:rPr lang="en-US" dirty="0"/>
+              <a:t> decides if at least one element of a list satisfies a predicate.</a:t>
+            </a:r>
+          </a:p>
+        </p:txBody>
+      </p:sp>
+      <p:sp>
+        <p:nvSpPr>
+          <p:cNvPr id="36867" name="Text Box 4"/>
+          <p:cNvSpPr txBox="1">
+            <a:spLocks noChangeArrowheads="1"/>
+          </p:cNvSpPr>
+          <p:nvPr/>
+        </p:nvSpPr>
+        <p:spPr bwMode="auto">
+          <a:xfrm>
+            <a:off x="2688530" y="3325669"/>
+            <a:ext cx="6102350" cy="965200"/>
+          </a:xfrm>
+          <a:prstGeom prst="rect">
+            <a:avLst/>
+          </a:prstGeom>
+          <a:solidFill>
+            <a:schemeClr val="accent1"/>
+          </a:solidFill>
+          <a:ln>
+            <a:noFill/>
+          </a:ln>
+          <a:extLst>
+            <a:ext uri="{91240B29-F687-4f45-9708-019B960494DF}">
+              <a14:hiddenLine xmlns="" xmlns:a14="http://schemas.microsoft.com/office/drawing/2010/main" w="12700" cap="sq">
+                <a:solidFill>
+                  <a:srgbClr val="000000"/>
+                </a:solidFill>
+                <a:miter lim="800000"/>
+                <a:headEnd/>
+                <a:tailEnd/>
+              </a14:hiddenLine>
+            </a:ext>
+          </a:extLst>
+        </p:spPr>
+        <p:txBody>
+          <a:bodyPr wrap="none" anchor="ctr">
+            <a:spAutoFit/>
+          </a:bodyPr>
+          <a:lstStyle>
+            <a:lvl1pPr>
+              <a:defRPr sz="2800">
+                <a:solidFill>
+                  <a:schemeClr val="tx1"/>
+                </a:solidFill>
+                <a:latin typeface="Tahoma" charset="0"/>
+                <a:ea typeface="ＭＳ Ｐゴシック" charset="0"/>
+                <a:cs typeface="ＭＳ Ｐゴシック" charset="0"/>
+              </a:defRPr>
+            </a:lvl1pPr>
+            <a:lvl2pPr marL="742950" indent="-285750">
+              <a:defRPr sz="2800">
+                <a:solidFill>
+                  <a:schemeClr val="tx1"/>
+                </a:solidFill>
+                <a:latin typeface="Tahoma" charset="0"/>
+                <a:ea typeface="ＭＳ Ｐゴシック" charset="0"/>
+              </a:defRPr>
+            </a:lvl2pPr>
+            <a:lvl3pPr marL="1143000" indent="-228600">
+              <a:defRPr sz="2800">
+                <a:solidFill>
+                  <a:schemeClr val="tx1"/>
+                </a:solidFill>
+                <a:latin typeface="Tahoma" charset="0"/>
+                <a:ea typeface="ＭＳ Ｐゴシック" charset="0"/>
+              </a:defRPr>
+            </a:lvl3pPr>
+            <a:lvl4pPr marL="1600200" indent="-228600">
+              <a:defRPr sz="2800">
+                <a:solidFill>
+                  <a:schemeClr val="tx1"/>
+                </a:solidFill>
+                <a:latin typeface="Tahoma" charset="0"/>
+                <a:ea typeface="ＭＳ Ｐゴシック" charset="0"/>
+              </a:defRPr>
+            </a:lvl4pPr>
+            <a:lvl5pPr marL="2057400" indent="-228600">
+              <a:defRPr sz="2800">
+                <a:solidFill>
+                  <a:schemeClr val="tx1"/>
+                </a:solidFill>
+                <a:latin typeface="Tahoma" charset="0"/>
+                <a:ea typeface="ＭＳ Ｐゴシック" charset="0"/>
+              </a:defRPr>
+            </a:lvl5pPr>
+            <a:lvl6pPr marL="2514600" indent="-228600" eaLnBrk="0" fontAlgn="base" hangingPunct="0">
+              <a:spcBef>
+                <a:spcPct val="0"/>
+              </a:spcBef>
+              <a:spcAft>
+                <a:spcPct val="0"/>
+              </a:spcAft>
+              <a:defRPr sz="2800">
+                <a:solidFill>
+                  <a:schemeClr val="tx1"/>
+                </a:solidFill>
+                <a:latin typeface="Tahoma" charset="0"/>
+                <a:ea typeface="ＭＳ Ｐゴシック" charset="0"/>
+              </a:defRPr>
+            </a:lvl6pPr>
+            <a:lvl7pPr marL="2971800" indent="-228600" eaLnBrk="0" fontAlgn="base" hangingPunct="0">
+              <a:spcBef>
+                <a:spcPct val="0"/>
+              </a:spcBef>
+              <a:spcAft>
+                <a:spcPct val="0"/>
+              </a:spcAft>
+              <a:defRPr sz="2800">
+                <a:solidFill>
+                  <a:schemeClr val="tx1"/>
+                </a:solidFill>
+                <a:latin typeface="Tahoma" charset="0"/>
+                <a:ea typeface="ＭＳ Ｐゴシック" charset="0"/>
+              </a:defRPr>
+            </a:lvl7pPr>
+            <a:lvl8pPr marL="3429000" indent="-228600" eaLnBrk="0" fontAlgn="base" hangingPunct="0">
+              <a:spcBef>
+                <a:spcPct val="0"/>
+              </a:spcBef>
+              <a:spcAft>
+                <a:spcPct val="0"/>
+              </a:spcAft>
+              <a:defRPr sz="2800">
+                <a:solidFill>
+                  <a:schemeClr val="tx1"/>
+                </a:solidFill>
+                <a:latin typeface="Tahoma" charset="0"/>
+                <a:ea typeface="ＭＳ Ｐゴシック" charset="0"/>
+              </a:defRPr>
+            </a:lvl8pPr>
+            <a:lvl9pPr marL="3886200" indent="-228600" eaLnBrk="0" fontAlgn="base" hangingPunct="0">
+              <a:spcBef>
+                <a:spcPct val="0"/>
+              </a:spcBef>
+              <a:spcAft>
+                <a:spcPct val="0"/>
+              </a:spcAft>
+              <a:defRPr sz="2800">
+                <a:solidFill>
+                  <a:schemeClr val="tx1"/>
+                </a:solidFill>
+                <a:latin typeface="Tahoma" charset="0"/>
+                <a:ea typeface="ＭＳ Ｐゴシック" charset="0"/>
+              </a:defRPr>
+            </a:lvl9pPr>
+          </a:lstStyle>
+          <a:p>
+            <a:pPr>
+              <a:lnSpc>
+                <a:spcPct val="120000"/>
+              </a:lnSpc>
+            </a:pPr>
+            <a:r>
+              <a:rPr lang="en-US" sz="2400" dirty="0">
+                <a:latin typeface="Lucida Sans Typewriter" charset="0"/>
+              </a:rPr>
+              <a:t>any :: (a </a:t>
+            </a:r>
+            <a:r>
+              <a:rPr lang="en-US" sz="2400" dirty="0">
+                <a:latin typeface="Lucida Sans Typewriter" charset="0"/>
+                <a:sym typeface="Symbol" charset="0"/>
+              </a:rPr>
+              <a:t></a:t>
+            </a:r>
+            <a:r>
+              <a:rPr lang="en-US" sz="2400" dirty="0">
+                <a:latin typeface="Lucida Sans Typewriter" charset="0"/>
+              </a:rPr>
+              <a:t> Bool) </a:t>
+            </a:r>
+            <a:r>
+              <a:rPr lang="en-US" sz="2400" dirty="0">
+                <a:latin typeface="Lucida Sans Typewriter" charset="0"/>
+                <a:sym typeface="Symbol" charset="0"/>
+              </a:rPr>
+              <a:t></a:t>
+            </a:r>
+            <a:r>
+              <a:rPr lang="en-US" sz="2400" dirty="0">
+                <a:latin typeface="Lucida Sans Typewriter" charset="0"/>
+              </a:rPr>
+              <a:t> [a] </a:t>
+            </a:r>
+            <a:r>
+              <a:rPr lang="en-US" sz="2400" dirty="0">
+                <a:latin typeface="Lucida Sans Typewriter" charset="0"/>
+                <a:sym typeface="Symbol" charset="0"/>
+              </a:rPr>
+              <a:t></a:t>
+            </a:r>
+            <a:r>
+              <a:rPr lang="en-US" sz="2400" dirty="0">
+                <a:latin typeface="Lucida Sans Typewriter" charset="0"/>
+              </a:rPr>
+              <a:t> Bool</a:t>
+            </a:r>
+          </a:p>
+          <a:p>
+            <a:pPr>
+              <a:lnSpc>
+                <a:spcPct val="120000"/>
+              </a:lnSpc>
+            </a:pPr>
+            <a:r>
+              <a:rPr lang="en-US" sz="2400" dirty="0">
+                <a:latin typeface="Lucida Sans Typewriter" charset="0"/>
+              </a:rPr>
+              <a:t>any p </a:t>
+            </a:r>
+            <a:r>
+              <a:rPr lang="en-US" sz="2400" dirty="0" err="1">
+                <a:latin typeface="Lucida Sans Typewriter" charset="0"/>
+              </a:rPr>
+              <a:t>xs</a:t>
+            </a:r>
+            <a:r>
+              <a:rPr lang="en-US" sz="2400" dirty="0">
+                <a:latin typeface="Lucida Sans Typewriter" charset="0"/>
+              </a:rPr>
+              <a:t> = or [p x | x </a:t>
+            </a:r>
+            <a:r>
+              <a:rPr lang="en-US" sz="2400" dirty="0">
+                <a:latin typeface="Lucida Sans Typewriter" charset="0"/>
+                <a:sym typeface="Symbol" charset="0"/>
+              </a:rPr>
+              <a:t></a:t>
+            </a:r>
+            <a:r>
+              <a:rPr lang="en-US" sz="2400" dirty="0">
+                <a:latin typeface="Lucida Sans Typewriter" charset="0"/>
+              </a:rPr>
+              <a:t> </a:t>
+            </a:r>
+            <a:r>
+              <a:rPr lang="en-US" sz="2400" dirty="0" err="1">
+                <a:latin typeface="Lucida Sans Typewriter" charset="0"/>
+              </a:rPr>
+              <a:t>xs</a:t>
+            </a:r>
+            <a:r>
+              <a:rPr lang="en-US" sz="2400" dirty="0">
+                <a:latin typeface="Lucida Sans Typewriter" charset="0"/>
+              </a:rPr>
+              <a:t>]</a:t>
+            </a:r>
+          </a:p>
+        </p:txBody>
+      </p:sp>
+      <p:sp>
+        <p:nvSpPr>
+          <p:cNvPr id="36868" name="Text Box 5"/>
+          <p:cNvSpPr txBox="1">
+            <a:spLocks noChangeArrowheads="1"/>
+          </p:cNvSpPr>
+          <p:nvPr/>
+        </p:nvSpPr>
+        <p:spPr bwMode="auto">
+          <a:xfrm>
+            <a:off x="988556" y="4470596"/>
+            <a:ext cx="8308975" cy="519113"/>
+          </a:xfrm>
+          <a:prstGeom prst="rect">
+            <a:avLst/>
+          </a:prstGeom>
+          <a:noFill/>
+          <a:ln>
+            <a:noFill/>
+          </a:ln>
+          <a:extLst>
+            <a:ext uri="{909E8E84-426E-40dd-AFC4-6F175D3DCCD1}">
+              <a14:hiddenFill xmlns="" xmlns:a14="http://schemas.microsoft.com/office/drawing/2010/main">
+                <a:solidFill>
+                  <a:srgbClr val="FFFFFF"/>
+                </a:solidFill>
+              </a14:hiddenFill>
+            </a:ext>
+            <a:ext uri="{91240B29-F687-4f45-9708-019B960494DF}">
+              <a14:hiddenLine xmlns="" xmlns:a14="http://schemas.microsoft.com/office/drawing/2010/main" w="12700" cap="sq">
                 <a:solidFill>
                   <a:srgbClr val="000000"/>
                 </a:solidFill>
@@ -26708,431 +27130,6 @@
           <a:p>
             <a:r>
               <a:rPr lang="en-US" dirty="0"/>
-              <a:t>Dually, the library function </a:t>
-            </a:r>
-            <a:r>
-              <a:rPr lang="en-US" u="sng" dirty="0"/>
-              <a:t>any</a:t>
-            </a:r>
-            <a:r>
-              <a:rPr lang="en-US" dirty="0"/>
-              <a:t> decides if at least</a:t>
-            </a:r>
-          </a:p>
-          <a:p>
-            <a:r>
-              <a:rPr lang="en-US" dirty="0"/>
-              <a:t>one element of a list satisfies a predicate.</a:t>
-            </a:r>
-          </a:p>
-        </p:txBody>
-      </p:sp>
-      <p:sp>
-        <p:nvSpPr>
-          <p:cNvPr id="36867" name="Text Box 4"/>
-          <p:cNvSpPr txBox="1">
-            <a:spLocks noChangeArrowheads="1"/>
-          </p:cNvSpPr>
-          <p:nvPr/>
-        </p:nvSpPr>
-        <p:spPr bwMode="auto">
-          <a:xfrm>
-            <a:off x="2701782" y="3220236"/>
-            <a:ext cx="6102350" cy="965200"/>
-          </a:xfrm>
-          <a:prstGeom prst="rect">
-            <a:avLst/>
-          </a:prstGeom>
-          <a:solidFill>
-            <a:schemeClr val="accent1"/>
-          </a:solidFill>
-          <a:ln>
-            <a:noFill/>
-          </a:ln>
-          <a:extLst>
-            <a:ext uri="{91240B29-F687-4f45-9708-019B960494DF}">
-              <a14:hiddenLine xmlns:a14="http://schemas.microsoft.com/office/drawing/2010/main" xmlns="" w="12700" cap="sq">
-                <a:solidFill>
-                  <a:srgbClr val="000000"/>
-                </a:solidFill>
-                <a:miter lim="800000"/>
-                <a:headEnd/>
-                <a:tailEnd/>
-              </a14:hiddenLine>
-            </a:ext>
-          </a:extLst>
-        </p:spPr>
-        <p:txBody>
-          <a:bodyPr wrap="none" anchor="ctr">
-            <a:spAutoFit/>
-          </a:bodyPr>
-          <a:lstStyle>
-            <a:lvl1pPr>
-              <a:defRPr sz="2800">
-                <a:solidFill>
-                  <a:schemeClr val="tx1"/>
-                </a:solidFill>
-                <a:latin typeface="Tahoma" charset="0"/>
-                <a:ea typeface="ＭＳ Ｐゴシック" charset="0"/>
-                <a:cs typeface="ＭＳ Ｐゴシック" charset="0"/>
-              </a:defRPr>
-            </a:lvl1pPr>
-            <a:lvl2pPr marL="742950" indent="-285750">
-              <a:defRPr sz="2800">
-                <a:solidFill>
-                  <a:schemeClr val="tx1"/>
-                </a:solidFill>
-                <a:latin typeface="Tahoma" charset="0"/>
-                <a:ea typeface="ＭＳ Ｐゴシック" charset="0"/>
-              </a:defRPr>
-            </a:lvl2pPr>
-            <a:lvl3pPr marL="1143000" indent="-228600">
-              <a:defRPr sz="2800">
-                <a:solidFill>
-                  <a:schemeClr val="tx1"/>
-                </a:solidFill>
-                <a:latin typeface="Tahoma" charset="0"/>
-                <a:ea typeface="ＭＳ Ｐゴシック" charset="0"/>
-              </a:defRPr>
-            </a:lvl3pPr>
-            <a:lvl4pPr marL="1600200" indent="-228600">
-              <a:defRPr sz="2800">
-                <a:solidFill>
-                  <a:schemeClr val="tx1"/>
-                </a:solidFill>
-                <a:latin typeface="Tahoma" charset="0"/>
-                <a:ea typeface="ＭＳ Ｐゴシック" charset="0"/>
-              </a:defRPr>
-            </a:lvl4pPr>
-            <a:lvl5pPr marL="2057400" indent="-228600">
-              <a:defRPr sz="2800">
-                <a:solidFill>
-                  <a:schemeClr val="tx1"/>
-                </a:solidFill>
-                <a:latin typeface="Tahoma" charset="0"/>
-                <a:ea typeface="ＭＳ Ｐゴシック" charset="0"/>
-              </a:defRPr>
-            </a:lvl5pPr>
-            <a:lvl6pPr marL="2514600" indent="-228600" eaLnBrk="0" fontAlgn="base" hangingPunct="0">
-              <a:spcBef>
-                <a:spcPct val="0"/>
-              </a:spcBef>
-              <a:spcAft>
-                <a:spcPct val="0"/>
-              </a:spcAft>
-              <a:defRPr sz="2800">
-                <a:solidFill>
-                  <a:schemeClr val="tx1"/>
-                </a:solidFill>
-                <a:latin typeface="Tahoma" charset="0"/>
-                <a:ea typeface="ＭＳ Ｐゴシック" charset="0"/>
-              </a:defRPr>
-            </a:lvl6pPr>
-            <a:lvl7pPr marL="2971800" indent="-228600" eaLnBrk="0" fontAlgn="base" hangingPunct="0">
-              <a:spcBef>
-                <a:spcPct val="0"/>
-              </a:spcBef>
-              <a:spcAft>
-                <a:spcPct val="0"/>
-              </a:spcAft>
-              <a:defRPr sz="2800">
-                <a:solidFill>
-                  <a:schemeClr val="tx1"/>
-                </a:solidFill>
-                <a:latin typeface="Tahoma" charset="0"/>
-                <a:ea typeface="ＭＳ Ｐゴシック" charset="0"/>
-              </a:defRPr>
-            </a:lvl7pPr>
-            <a:lvl8pPr marL="3429000" indent="-228600" eaLnBrk="0" fontAlgn="base" hangingPunct="0">
-              <a:spcBef>
-                <a:spcPct val="0"/>
-              </a:spcBef>
-              <a:spcAft>
-                <a:spcPct val="0"/>
-              </a:spcAft>
-              <a:defRPr sz="2800">
-                <a:solidFill>
-                  <a:schemeClr val="tx1"/>
-                </a:solidFill>
-                <a:latin typeface="Tahoma" charset="0"/>
-                <a:ea typeface="ＭＳ Ｐゴシック" charset="0"/>
-              </a:defRPr>
-            </a:lvl8pPr>
-            <a:lvl9pPr marL="3886200" indent="-228600" eaLnBrk="0" fontAlgn="base" hangingPunct="0">
-              <a:spcBef>
-                <a:spcPct val="0"/>
-              </a:spcBef>
-              <a:spcAft>
-                <a:spcPct val="0"/>
-              </a:spcAft>
-              <a:defRPr sz="2800">
-                <a:solidFill>
-                  <a:schemeClr val="tx1"/>
-                </a:solidFill>
-                <a:latin typeface="Tahoma" charset="0"/>
-                <a:ea typeface="ＭＳ Ｐゴシック" charset="0"/>
-              </a:defRPr>
-            </a:lvl9pPr>
-          </a:lstStyle>
-          <a:p>
-            <a:pPr>
-              <a:lnSpc>
-                <a:spcPct val="120000"/>
-              </a:lnSpc>
-            </a:pPr>
-            <a:r>
-              <a:rPr lang="en-US" sz="2400" dirty="0">
-                <a:latin typeface="Lucida Sans Typewriter" charset="0"/>
-              </a:rPr>
-              <a:t>any :: (a </a:t>
-            </a:r>
-            <a:r>
-              <a:rPr lang="en-US" sz="2400" dirty="0">
-                <a:latin typeface="Lucida Sans Typewriter" charset="0"/>
-                <a:sym typeface="Symbol" charset="0"/>
-              </a:rPr>
-              <a:t></a:t>
-            </a:r>
-            <a:r>
-              <a:rPr lang="en-US" sz="2400" dirty="0">
-                <a:latin typeface="Lucida Sans Typewriter" charset="0"/>
-              </a:rPr>
-              <a:t> Bool) </a:t>
-            </a:r>
-            <a:r>
-              <a:rPr lang="en-US" sz="2400" dirty="0">
-                <a:latin typeface="Lucida Sans Typewriter" charset="0"/>
-                <a:sym typeface="Symbol" charset="0"/>
-              </a:rPr>
-              <a:t></a:t>
-            </a:r>
-            <a:r>
-              <a:rPr lang="en-US" sz="2400" dirty="0">
-                <a:latin typeface="Lucida Sans Typewriter" charset="0"/>
-              </a:rPr>
-              <a:t> [a] </a:t>
-            </a:r>
-            <a:r>
-              <a:rPr lang="en-US" sz="2400" dirty="0">
-                <a:latin typeface="Lucida Sans Typewriter" charset="0"/>
-                <a:sym typeface="Symbol" charset="0"/>
-              </a:rPr>
-              <a:t></a:t>
-            </a:r>
-            <a:r>
-              <a:rPr lang="en-US" sz="2400" dirty="0">
-                <a:latin typeface="Lucida Sans Typewriter" charset="0"/>
-              </a:rPr>
-              <a:t> Bool</a:t>
-            </a:r>
-          </a:p>
-          <a:p>
-            <a:pPr>
-              <a:lnSpc>
-                <a:spcPct val="120000"/>
-              </a:lnSpc>
-            </a:pPr>
-            <a:r>
-              <a:rPr lang="en-US" sz="2400" dirty="0">
-                <a:latin typeface="Lucida Sans Typewriter" charset="0"/>
-              </a:rPr>
-              <a:t>any p </a:t>
-            </a:r>
-            <a:r>
-              <a:rPr lang="en-US" sz="2400" dirty="0" err="1">
-                <a:latin typeface="Lucida Sans Typewriter" charset="0"/>
-              </a:rPr>
-              <a:t>xs</a:t>
-            </a:r>
-            <a:r>
-              <a:rPr lang="en-US" sz="2400" dirty="0">
-                <a:latin typeface="Lucida Sans Typewriter" charset="0"/>
-              </a:rPr>
-              <a:t> = or [p x | x </a:t>
-            </a:r>
-            <a:r>
-              <a:rPr lang="en-US" sz="2400" dirty="0">
-                <a:latin typeface="Lucida Sans Typewriter" charset="0"/>
-                <a:sym typeface="Symbol" charset="0"/>
-              </a:rPr>
-              <a:t></a:t>
-            </a:r>
-            <a:r>
-              <a:rPr lang="en-US" sz="2400" dirty="0">
-                <a:latin typeface="Lucida Sans Typewriter" charset="0"/>
-              </a:rPr>
-              <a:t> </a:t>
-            </a:r>
-            <a:r>
-              <a:rPr lang="en-US" sz="2400" dirty="0" err="1">
-                <a:latin typeface="Lucida Sans Typewriter" charset="0"/>
-              </a:rPr>
-              <a:t>xs</a:t>
-            </a:r>
-            <a:r>
-              <a:rPr lang="en-US" sz="2400" dirty="0">
-                <a:latin typeface="Lucida Sans Typewriter" charset="0"/>
-              </a:rPr>
-              <a:t>]</a:t>
-            </a:r>
-          </a:p>
-        </p:txBody>
-      </p:sp>
-      <p:sp>
-        <p:nvSpPr>
-          <p:cNvPr id="36868" name="Text Box 5"/>
-          <p:cNvSpPr txBox="1">
-            <a:spLocks noChangeArrowheads="1"/>
-          </p:cNvSpPr>
-          <p:nvPr/>
-        </p:nvSpPr>
-        <p:spPr bwMode="auto">
-          <a:xfrm>
-            <a:off x="975304" y="4290869"/>
-            <a:ext cx="8308975" cy="519113"/>
-          </a:xfrm>
-          <a:prstGeom prst="rect">
-            <a:avLst/>
-          </a:prstGeom>
-          <a:noFill/>
-          <a:ln>
-            <a:noFill/>
-          </a:ln>
-          <a:extLst>
-            <a:ext uri="{909E8E84-426E-40dd-AFC4-6F175D3DCCD1}">
-              <a14:hiddenFill xmlns:a14="http://schemas.microsoft.com/office/drawing/2010/main" xmlns="">
-                <a:solidFill>
-                  <a:srgbClr val="FFFFFF"/>
-                </a:solidFill>
-              </a14:hiddenFill>
-            </a:ext>
-            <a:ext uri="{91240B29-F687-4f45-9708-019B960494DF}">
-              <a14:hiddenLine xmlns:a14="http://schemas.microsoft.com/office/drawing/2010/main" xmlns="" w="12700" cap="sq">
-                <a:solidFill>
-                  <a:srgbClr val="000000"/>
-                </a:solidFill>
-                <a:miter lim="800000"/>
-                <a:headEnd/>
-                <a:tailEnd/>
-              </a14:hiddenLine>
-            </a:ext>
-          </a:extLst>
-        </p:spPr>
-        <p:txBody>
-          <a:bodyPr anchor="ctr">
-            <a:spAutoFit/>
-          </a:bodyPr>
-          <a:lstStyle>
-            <a:lvl1pPr>
-              <a:defRPr sz="2800">
-                <a:solidFill>
-                  <a:schemeClr val="tx1"/>
-                </a:solidFill>
-                <a:latin typeface="Tahoma" charset="0"/>
-                <a:ea typeface="ＭＳ Ｐゴシック" charset="0"/>
-                <a:cs typeface="ＭＳ Ｐゴシック" charset="0"/>
-              </a:defRPr>
-            </a:lvl1pPr>
-            <a:lvl2pPr marL="742950" indent="-285750">
-              <a:defRPr sz="2800">
-                <a:solidFill>
-                  <a:schemeClr val="tx1"/>
-                </a:solidFill>
-                <a:latin typeface="Tahoma" charset="0"/>
-                <a:ea typeface="ＭＳ Ｐゴシック" charset="0"/>
-              </a:defRPr>
-            </a:lvl2pPr>
-            <a:lvl3pPr marL="1143000" indent="-228600">
-              <a:defRPr sz="2800">
-                <a:solidFill>
-                  <a:schemeClr val="tx1"/>
-                </a:solidFill>
-                <a:latin typeface="Tahoma" charset="0"/>
-                <a:ea typeface="ＭＳ Ｐゴシック" charset="0"/>
-              </a:defRPr>
-            </a:lvl3pPr>
-            <a:lvl4pPr marL="1600200" indent="-228600">
-              <a:defRPr sz="2800">
-                <a:solidFill>
-                  <a:schemeClr val="tx1"/>
-                </a:solidFill>
-                <a:latin typeface="Tahoma" charset="0"/>
-                <a:ea typeface="ＭＳ Ｐゴシック" charset="0"/>
-              </a:defRPr>
-            </a:lvl4pPr>
-            <a:lvl5pPr marL="2057400" indent="-228600">
-              <a:defRPr sz="2800">
-                <a:solidFill>
-                  <a:schemeClr val="tx1"/>
-                </a:solidFill>
-                <a:latin typeface="Tahoma" charset="0"/>
-                <a:ea typeface="ＭＳ Ｐゴシック" charset="0"/>
-              </a:defRPr>
-            </a:lvl5pPr>
-            <a:lvl6pPr marL="2514600" indent="-228600" eaLnBrk="0" fontAlgn="base" hangingPunct="0">
-              <a:spcBef>
-                <a:spcPct val="0"/>
-              </a:spcBef>
-              <a:spcAft>
-                <a:spcPct val="0"/>
-              </a:spcAft>
-              <a:defRPr sz="2800">
-                <a:solidFill>
-                  <a:schemeClr val="tx1"/>
-                </a:solidFill>
-                <a:latin typeface="Tahoma" charset="0"/>
-                <a:ea typeface="ＭＳ Ｐゴシック" charset="0"/>
-              </a:defRPr>
-            </a:lvl6pPr>
-            <a:lvl7pPr marL="2971800" indent="-228600" eaLnBrk="0" fontAlgn="base" hangingPunct="0">
-              <a:spcBef>
-                <a:spcPct val="0"/>
-              </a:spcBef>
-              <a:spcAft>
-                <a:spcPct val="0"/>
-              </a:spcAft>
-              <a:defRPr sz="2800">
-                <a:solidFill>
-                  <a:schemeClr val="tx1"/>
-                </a:solidFill>
-                <a:latin typeface="Tahoma" charset="0"/>
-                <a:ea typeface="ＭＳ Ｐゴシック" charset="0"/>
-              </a:defRPr>
-            </a:lvl7pPr>
-            <a:lvl8pPr marL="3429000" indent="-228600" eaLnBrk="0" fontAlgn="base" hangingPunct="0">
-              <a:spcBef>
-                <a:spcPct val="0"/>
-              </a:spcBef>
-              <a:spcAft>
-                <a:spcPct val="0"/>
-              </a:spcAft>
-              <a:defRPr sz="2800">
-                <a:solidFill>
-                  <a:schemeClr val="tx1"/>
-                </a:solidFill>
-                <a:latin typeface="Tahoma" charset="0"/>
-                <a:ea typeface="ＭＳ Ｐゴシック" charset="0"/>
-              </a:defRPr>
-            </a:lvl8pPr>
-            <a:lvl9pPr marL="3886200" indent="-228600" eaLnBrk="0" fontAlgn="base" hangingPunct="0">
-              <a:spcBef>
-                <a:spcPct val="0"/>
-              </a:spcBef>
-              <a:spcAft>
-                <a:spcPct val="0"/>
-              </a:spcAft>
-              <a:defRPr sz="2800">
-                <a:solidFill>
-                  <a:schemeClr val="tx1"/>
-                </a:solidFill>
-                <a:latin typeface="Tahoma" charset="0"/>
-                <a:ea typeface="ＭＳ Ｐゴシック" charset="0"/>
-              </a:defRPr>
-            </a:lvl9pPr>
-          </a:lstStyle>
-          <a:p>
-            <a:r>
-              <a:rPr lang="en-US" dirty="0"/>
               <a:t>For example:</a:t>
             </a:r>
           </a:p>
@@ -27148,7 +27145,7 @@
         </p:nvSpPr>
         <p:spPr bwMode="auto">
           <a:xfrm>
-            <a:off x="2951163" y="4951413"/>
+            <a:off x="2990920" y="5175107"/>
             <a:ext cx="4635500" cy="1200150"/>
           </a:xfrm>
           <a:prstGeom prst="rect">
@@ -27162,7 +27159,7 @@
           </a:ln>
           <a:extLst>
             <a:ext uri="{91240B29-F687-4f45-9708-019B960494DF}">
-              <a14:hiddenLine xmlns:a14="http://schemas.microsoft.com/office/drawing/2010/main" xmlns="" w="12700" cap="sq">
+              <a14:hiddenLine xmlns="" xmlns:a14="http://schemas.microsoft.com/office/drawing/2010/main" w="12700" cap="sq">
                 <a:solidFill>
                   <a:srgbClr val="000000"/>
                 </a:solidFill>
@@ -27819,14 +27816,14 @@
           <a:ln/>
           <a:extLst>
             <a:ext uri="{909E8E84-426E-40dd-AFC4-6F175D3DCCD1}">
-              <a14:hiddenFill xmlns:a14="http://schemas.microsoft.com/office/drawing/2010/main" xmlns="">
+              <a14:hiddenFill xmlns="" xmlns:a14="http://schemas.microsoft.com/office/drawing/2010/main">
                 <a:solidFill>
                   <a:srgbClr val="FFFFFF"/>
                 </a:solidFill>
               </a14:hiddenFill>
             </a:ext>
             <a:ext uri="{91240B29-F687-4f45-9708-019B960494DF}">
-              <a14:hiddenLine xmlns:a14="http://schemas.microsoft.com/office/drawing/2010/main" xmlns="" w="9525">
+              <a14:hiddenLine xmlns="" xmlns:a14="http://schemas.microsoft.com/office/drawing/2010/main" w="9525">
                 <a:solidFill>
                   <a:srgbClr val="000000"/>
                 </a:solidFill>
@@ -27979,14 +27976,14 @@
           </a:ln>
           <a:extLst>
             <a:ext uri="{909E8E84-426E-40dd-AFC4-6F175D3DCCD1}">
-              <a14:hiddenFill xmlns:a14="http://schemas.microsoft.com/office/drawing/2010/main" xmlns="">
+              <a14:hiddenFill xmlns="" xmlns:a14="http://schemas.microsoft.com/office/drawing/2010/main">
                 <a:solidFill>
                   <a:srgbClr val="FFFFFF"/>
                 </a:solidFill>
               </a14:hiddenFill>
             </a:ext>
             <a:ext uri="{91240B29-F687-4f45-9708-019B960494DF}">
-              <a14:hiddenLine xmlns:a14="http://schemas.microsoft.com/office/drawing/2010/main" xmlns="" w="12700" cap="sq">
+              <a14:hiddenLine xmlns="" xmlns:a14="http://schemas.microsoft.com/office/drawing/2010/main" w="12700" cap="sq">
                 <a:solidFill>
                   <a:srgbClr val="000000"/>
                 </a:solidFill>
@@ -28149,7 +28146,7 @@
           </a:ln>
           <a:extLst>
             <a:ext uri="{91240B29-F687-4f45-9708-019B960494DF}">
-              <a14:hiddenLine xmlns:a14="http://schemas.microsoft.com/office/drawing/2010/main" xmlns="" w="12700" cap="sq">
+              <a14:hiddenLine xmlns="" xmlns:a14="http://schemas.microsoft.com/office/drawing/2010/main" w="12700" cap="sq">
                 <a:solidFill>
                   <a:srgbClr val="000000"/>
                 </a:solidFill>
@@ -28463,14 +28460,14 @@
           </a:ln>
           <a:extLst>
             <a:ext uri="{909E8E84-426E-40dd-AFC4-6F175D3DCCD1}">
-              <a14:hiddenFill xmlns:a14="http://schemas.microsoft.com/office/drawing/2010/main" xmlns="">
+              <a14:hiddenFill xmlns="" xmlns:a14="http://schemas.microsoft.com/office/drawing/2010/main">
                 <a:solidFill>
                   <a:srgbClr val="FFFFFF"/>
                 </a:solidFill>
               </a14:hiddenFill>
             </a:ext>
             <a:ext uri="{91240B29-F687-4f45-9708-019B960494DF}">
-              <a14:hiddenLine xmlns:a14="http://schemas.microsoft.com/office/drawing/2010/main" xmlns="" w="12700" cap="sq">
+              <a14:hiddenLine xmlns="" xmlns:a14="http://schemas.microsoft.com/office/drawing/2010/main" w="12700" cap="sq">
                 <a:solidFill>
                   <a:srgbClr val="000000"/>
                 </a:solidFill>
@@ -28625,7 +28622,7 @@
           </a:ln>
           <a:extLst>
             <a:ext uri="{91240B29-F687-4f45-9708-019B960494DF}">
-              <a14:hiddenLine xmlns:a14="http://schemas.microsoft.com/office/drawing/2010/main" xmlns="" w="12700" cap="sq">
+              <a14:hiddenLine xmlns="" xmlns:a14="http://schemas.microsoft.com/office/drawing/2010/main" w="12700" cap="sq">
                 <a:solidFill>
                   <a:srgbClr val="000000"/>
                 </a:solidFill>
@@ -29194,14 +29191,14 @@
           <a:ln/>
           <a:extLst>
             <a:ext uri="{909E8E84-426E-40dd-AFC4-6F175D3DCCD1}">
-              <a14:hiddenFill xmlns:a14="http://schemas.microsoft.com/office/drawing/2010/main" xmlns="">
+              <a14:hiddenFill xmlns="" xmlns:a14="http://schemas.microsoft.com/office/drawing/2010/main">
                 <a:solidFill>
                   <a:srgbClr val="FFFFFF"/>
                 </a:solidFill>
               </a14:hiddenFill>
             </a:ext>
             <a:ext uri="{91240B29-F687-4f45-9708-019B960494DF}">
-              <a14:hiddenLine xmlns:a14="http://schemas.microsoft.com/office/drawing/2010/main" xmlns="" w="9525">
+              <a14:hiddenLine xmlns="" xmlns:a14="http://schemas.microsoft.com/office/drawing/2010/main" w="9525">
                 <a:solidFill>
                   <a:srgbClr val="000000"/>
                 </a:solidFill>
@@ -29354,14 +29351,14 @@
           </a:ln>
           <a:extLst>
             <a:ext uri="{909E8E84-426E-40dd-AFC4-6F175D3DCCD1}">
-              <a14:hiddenFill xmlns:a14="http://schemas.microsoft.com/office/drawing/2010/main" xmlns="">
+              <a14:hiddenFill xmlns="" xmlns:a14="http://schemas.microsoft.com/office/drawing/2010/main">
                 <a:solidFill>
                   <a:srgbClr val="FFFFFF"/>
                 </a:solidFill>
               </a14:hiddenFill>
             </a:ext>
             <a:ext uri="{91240B29-F687-4f45-9708-019B960494DF}">
-              <a14:hiddenLine xmlns:a14="http://schemas.microsoft.com/office/drawing/2010/main" xmlns="" w="12700" cap="sq">
+              <a14:hiddenLine xmlns="" xmlns:a14="http://schemas.microsoft.com/office/drawing/2010/main" w="12700" cap="sq">
                 <a:solidFill>
                   <a:srgbClr val="000000"/>
                 </a:solidFill>
@@ -29524,7 +29521,7 @@
           </a:ln>
           <a:extLst>
             <a:ext uri="{91240B29-F687-4f45-9708-019B960494DF}">
-              <a14:hiddenLine xmlns:a14="http://schemas.microsoft.com/office/drawing/2010/main" xmlns="" w="12700" cap="sq">
+              <a14:hiddenLine xmlns="" xmlns:a14="http://schemas.microsoft.com/office/drawing/2010/main" w="12700" cap="sq">
                 <a:solidFill>
                   <a:srgbClr val="000000"/>
                 </a:solidFill>
@@ -29847,14 +29844,14 @@
           </a:ln>
           <a:extLst>
             <a:ext uri="{909E8E84-426E-40dd-AFC4-6F175D3DCCD1}">
-              <a14:hiddenFill xmlns:a14="http://schemas.microsoft.com/office/drawing/2010/main" xmlns="">
+              <a14:hiddenFill xmlns="" xmlns:a14="http://schemas.microsoft.com/office/drawing/2010/main">
                 <a:solidFill>
                   <a:srgbClr val="FFFFFF"/>
                 </a:solidFill>
               </a14:hiddenFill>
             </a:ext>
             <a:ext uri="{91240B29-F687-4f45-9708-019B960494DF}">
-              <a14:hiddenLine xmlns:a14="http://schemas.microsoft.com/office/drawing/2010/main" xmlns="" w="12700" cap="sq">
+              <a14:hiddenLine xmlns="" xmlns:a14="http://schemas.microsoft.com/office/drawing/2010/main" w="12700" cap="sq">
                 <a:solidFill>
                   <a:srgbClr val="000000"/>
                 </a:solidFill>
@@ -30009,7 +30006,7 @@
           </a:ln>
           <a:extLst>
             <a:ext uri="{91240B29-F687-4f45-9708-019B960494DF}">
-              <a14:hiddenLine xmlns:a14="http://schemas.microsoft.com/office/drawing/2010/main" xmlns="" w="12700" cap="sq">
+              <a14:hiddenLine xmlns="" xmlns:a14="http://schemas.microsoft.com/office/drawing/2010/main" w="12700" cap="sq">
                 <a:solidFill>
                   <a:srgbClr val="000000"/>
                 </a:solidFill>
@@ -30891,14 +30888,14 @@
           <a:ln/>
           <a:extLst>
             <a:ext uri="{909E8E84-426E-40dd-AFC4-6F175D3DCCD1}">
-              <a14:hiddenFill xmlns:a14="http://schemas.microsoft.com/office/drawing/2010/main" xmlns="">
+              <a14:hiddenFill xmlns="" xmlns:a14="http://schemas.microsoft.com/office/drawing/2010/main">
                 <a:solidFill>
                   <a:srgbClr val="FFFFFF"/>
                 </a:solidFill>
               </a14:hiddenFill>
             </a:ext>
             <a:ext uri="{91240B29-F687-4f45-9708-019B960494DF}">
-              <a14:hiddenLine xmlns:a14="http://schemas.microsoft.com/office/drawing/2010/main" xmlns="" w="9525">
+              <a14:hiddenLine xmlns="" xmlns:a14="http://schemas.microsoft.com/office/drawing/2010/main" w="9525">
                 <a:solidFill>
                   <a:srgbClr val="000000"/>
                 </a:solidFill>
@@ -31051,14 +31048,14 @@
           </a:ln>
           <a:extLst>
             <a:ext uri="{909E8E84-426E-40dd-AFC4-6F175D3DCCD1}">
-              <a14:hiddenFill xmlns:a14="http://schemas.microsoft.com/office/drawing/2010/main" xmlns="">
+              <a14:hiddenFill xmlns="" xmlns:a14="http://schemas.microsoft.com/office/drawing/2010/main">
                 <a:solidFill>
                   <a:srgbClr val="FFFFFF"/>
                 </a:solidFill>
               </a14:hiddenFill>
             </a:ext>
             <a:ext uri="{91240B29-F687-4f45-9708-019B960494DF}">
-              <a14:hiddenLine xmlns:a14="http://schemas.microsoft.com/office/drawing/2010/main" xmlns="" w="9525">
+              <a14:hiddenLine xmlns="" xmlns:a14="http://schemas.microsoft.com/office/drawing/2010/main" w="9525">
                 <a:solidFill>
                   <a:srgbClr val="000000"/>
                 </a:solidFill>
@@ -31227,14 +31224,14 @@
           <a:ln/>
           <a:extLst>
             <a:ext uri="{909E8E84-426E-40dd-AFC4-6F175D3DCCD1}">
-              <a14:hiddenFill xmlns:a14="http://schemas.microsoft.com/office/drawing/2010/main" xmlns="">
+              <a14:hiddenFill xmlns="" xmlns:a14="http://schemas.microsoft.com/office/drawing/2010/main">
                 <a:solidFill>
                   <a:srgbClr val="FFFFFF"/>
                 </a:solidFill>
               </a14:hiddenFill>
             </a:ext>
             <a:ext uri="{91240B29-F687-4f45-9708-019B960494DF}">
-              <a14:hiddenLine xmlns:a14="http://schemas.microsoft.com/office/drawing/2010/main" xmlns="" w="9525">
+              <a14:hiddenLine xmlns="" xmlns:a14="http://schemas.microsoft.com/office/drawing/2010/main" w="9525">
                 <a:solidFill>
                   <a:srgbClr val="000000"/>
                 </a:solidFill>
@@ -31387,14 +31384,14 @@
           </a:ln>
           <a:extLst>
             <a:ext uri="{909E8E84-426E-40dd-AFC4-6F175D3DCCD1}">
-              <a14:hiddenFill xmlns:a14="http://schemas.microsoft.com/office/drawing/2010/main" xmlns="">
+              <a14:hiddenFill xmlns="" xmlns:a14="http://schemas.microsoft.com/office/drawing/2010/main">
                 <a:solidFill>
                   <a:srgbClr val="FFFFFF"/>
                 </a:solidFill>
               </a14:hiddenFill>
             </a:ext>
             <a:ext uri="{91240B29-F687-4f45-9708-019B960494DF}">
-              <a14:hiddenLine xmlns:a14="http://schemas.microsoft.com/office/drawing/2010/main" xmlns="" w="12700" cap="sq">
+              <a14:hiddenLine xmlns="" xmlns:a14="http://schemas.microsoft.com/office/drawing/2010/main" w="12700" cap="sq">
                 <a:solidFill>
                   <a:srgbClr val="000000"/>
                 </a:solidFill>
@@ -31557,7 +31554,7 @@
           </a:ln>
           <a:extLst>
             <a:ext uri="{91240B29-F687-4f45-9708-019B960494DF}">
-              <a14:hiddenLine xmlns:a14="http://schemas.microsoft.com/office/drawing/2010/main" xmlns="" w="12700" cap="sq">
+              <a14:hiddenLine xmlns="" xmlns:a14="http://schemas.microsoft.com/office/drawing/2010/main" w="12700" cap="sq">
                 <a:solidFill>
                   <a:srgbClr val="000000"/>
                 </a:solidFill>
@@ -31751,14 +31748,14 @@
           </a:ln>
           <a:extLst>
             <a:ext uri="{909E8E84-426E-40dd-AFC4-6F175D3DCCD1}">
-              <a14:hiddenFill xmlns:a14="http://schemas.microsoft.com/office/drawing/2010/main" xmlns="">
+              <a14:hiddenFill xmlns="" xmlns:a14="http://schemas.microsoft.com/office/drawing/2010/main">
                 <a:solidFill>
                   <a:srgbClr val="FFFFFF"/>
                 </a:solidFill>
               </a14:hiddenFill>
             </a:ext>
             <a:ext uri="{91240B29-F687-4f45-9708-019B960494DF}">
-              <a14:hiddenLine xmlns:a14="http://schemas.microsoft.com/office/drawing/2010/main" xmlns="" w="12700" cap="sq">
+              <a14:hiddenLine xmlns="" xmlns:a14="http://schemas.microsoft.com/office/drawing/2010/main" w="12700" cap="sq">
                 <a:solidFill>
                   <a:srgbClr val="000000"/>
                 </a:solidFill>
@@ -31913,7 +31910,7 @@
           </a:ln>
           <a:extLst>
             <a:ext uri="{91240B29-F687-4f45-9708-019B960494DF}">
-              <a14:hiddenLine xmlns:a14="http://schemas.microsoft.com/office/drawing/2010/main" xmlns="" w="12700" cap="sq">
+              <a14:hiddenLine xmlns="" xmlns:a14="http://schemas.microsoft.com/office/drawing/2010/main" w="12700" cap="sq">
                 <a:solidFill>
                   <a:srgbClr val="000000"/>
                 </a:solidFill>
@@ -32354,14 +32351,14 @@
           <a:ln/>
           <a:extLst>
             <a:ext uri="{909E8E84-426E-40dd-AFC4-6F175D3DCCD1}">
-              <a14:hiddenFill xmlns:a14="http://schemas.microsoft.com/office/drawing/2010/main" xmlns="">
+              <a14:hiddenFill xmlns="" xmlns:a14="http://schemas.microsoft.com/office/drawing/2010/main">
                 <a:solidFill>
                   <a:srgbClr val="FFFFFF"/>
                 </a:solidFill>
               </a14:hiddenFill>
             </a:ext>
             <a:ext uri="{91240B29-F687-4f45-9708-019B960494DF}">
-              <a14:hiddenLine xmlns:a14="http://schemas.microsoft.com/office/drawing/2010/main" xmlns="" w="9525">
+              <a14:hiddenLine xmlns="" xmlns:a14="http://schemas.microsoft.com/office/drawing/2010/main" w="9525">
                 <a:solidFill>
                   <a:srgbClr val="000000"/>
                 </a:solidFill>
@@ -32502,8 +32499,8 @@
         </p:nvSpPr>
         <p:spPr bwMode="auto">
           <a:xfrm>
-            <a:off x="1889957" y="4320308"/>
-            <a:ext cx="8404225" cy="946150"/>
+            <a:off x="1249731" y="4235592"/>
+            <a:ext cx="8256428" cy="946150"/>
           </a:xfrm>
           <a:prstGeom prst="rect">
             <a:avLst/>
@@ -32514,14 +32511,14 @@
           </a:ln>
           <a:extLst>
             <a:ext uri="{909E8E84-426E-40dd-AFC4-6F175D3DCCD1}">
-              <a14:hiddenFill xmlns:a14="http://schemas.microsoft.com/office/drawing/2010/main" xmlns="">
+              <a14:hiddenFill xmlns="" xmlns:a14="http://schemas.microsoft.com/office/drawing/2010/main">
                 <a:solidFill>
                   <a:srgbClr val="FFFFFF"/>
                 </a:solidFill>
               </a14:hiddenFill>
             </a:ext>
             <a:ext uri="{91240B29-F687-4f45-9708-019B960494DF}">
-              <a14:hiddenLine xmlns:a14="http://schemas.microsoft.com/office/drawing/2010/main" xmlns="" w="12700" cap="sq">
+              <a14:hiddenLine xmlns="" xmlns:a14="http://schemas.microsoft.com/office/drawing/2010/main" w="12700" cap="sq">
                 <a:solidFill>
                   <a:srgbClr val="000000"/>
                 </a:solidFill>
@@ -32533,7 +32530,7 @@
           </a:extLst>
         </p:spPr>
         <p:txBody>
-          <a:bodyPr anchor="ctr">
+          <a:bodyPr wrap="square" anchor="ctr">
             <a:spAutoFit/>
           </a:bodyPr>
           <a:lstStyle>
@@ -32662,8 +32659,8 @@
         </p:nvSpPr>
         <p:spPr bwMode="auto">
           <a:xfrm>
-            <a:off x="1240632" y="2163763"/>
-            <a:ext cx="8496300" cy="946150"/>
+            <a:off x="813323" y="2177786"/>
+            <a:ext cx="9347855" cy="946150"/>
           </a:xfrm>
           <a:prstGeom prst="rect">
             <a:avLst/>
@@ -32674,14 +32671,14 @@
           </a:ln>
           <a:extLst>
             <a:ext uri="{909E8E84-426E-40dd-AFC4-6F175D3DCCD1}">
-              <a14:hiddenFill xmlns:a14="http://schemas.microsoft.com/office/drawing/2010/main" xmlns="">
+              <a14:hiddenFill xmlns="" xmlns:a14="http://schemas.microsoft.com/office/drawing/2010/main">
                 <a:solidFill>
                   <a:srgbClr val="FFFFFF"/>
                 </a:solidFill>
               </a14:hiddenFill>
             </a:ext>
             <a:ext uri="{91240B29-F687-4f45-9708-019B960494DF}">
-              <a14:hiddenLine xmlns:a14="http://schemas.microsoft.com/office/drawing/2010/main" xmlns="" w="12700" cap="sq">
+              <a14:hiddenLine xmlns="" xmlns:a14="http://schemas.microsoft.com/office/drawing/2010/main" w="12700" cap="sq">
                 <a:solidFill>
                   <a:srgbClr val="000000"/>
                 </a:solidFill>
@@ -32693,7 +32690,7 @@
           </a:extLst>
         </p:spPr>
         <p:txBody>
-          <a:bodyPr anchor="ctr">
+          <a:bodyPr wrap="square" anchor="ctr">
             <a:spAutoFit/>
           </a:bodyPr>
           <a:lstStyle>
@@ -32822,7 +32819,7 @@
         </p:nvSpPr>
         <p:spPr bwMode="auto">
           <a:xfrm>
-            <a:off x="2926052" y="3519488"/>
+            <a:off x="3035356" y="3451164"/>
             <a:ext cx="4903787" cy="457200"/>
           </a:xfrm>
           <a:prstGeom prst="rect">
@@ -32836,7 +32833,7 @@
           </a:ln>
           <a:extLst>
             <a:ext uri="{91240B29-F687-4f45-9708-019B960494DF}">
-              <a14:hiddenLine xmlns:a14="http://schemas.microsoft.com/office/drawing/2010/main" xmlns="" w="12700" cap="sq">
+              <a14:hiddenLine xmlns="" xmlns:a14="http://schemas.microsoft.com/office/drawing/2010/main" w="12700" cap="sq">
                 <a:solidFill>
                   <a:srgbClr val="000000"/>
                 </a:solidFill>
@@ -33017,7 +33014,7 @@
         </p:nvSpPr>
         <p:spPr bwMode="auto">
           <a:xfrm>
-            <a:off x="2926052" y="5561419"/>
+            <a:off x="2698665" y="5508970"/>
             <a:ext cx="5577168" cy="1064009"/>
           </a:xfrm>
           <a:prstGeom prst="rect">
@@ -33031,7 +33028,7 @@
           </a:ln>
           <a:extLst>
             <a:ext uri="{91240B29-F687-4f45-9708-019B960494DF}">
-              <a14:hiddenLine xmlns:a14="http://schemas.microsoft.com/office/drawing/2010/main" xmlns="" w="12700" cap="sq">
+              <a14:hiddenLine xmlns="" xmlns:a14="http://schemas.microsoft.com/office/drawing/2010/main" w="12700" cap="sq">
                 <a:solidFill>
                   <a:srgbClr val="000000"/>
                 </a:solidFill>
@@ -33586,14 +33583,14 @@
           <a:ln/>
           <a:extLst>
             <a:ext uri="{909E8E84-426E-40dd-AFC4-6F175D3DCCD1}">
-              <a14:hiddenFill xmlns:a14="http://schemas.microsoft.com/office/drawing/2010/main" xmlns="">
+              <a14:hiddenFill xmlns="" xmlns:a14="http://schemas.microsoft.com/office/drawing/2010/main">
                 <a:solidFill>
                   <a:srgbClr val="FFFFFF"/>
                 </a:solidFill>
               </a14:hiddenFill>
             </a:ext>
             <a:ext uri="{91240B29-F687-4f45-9708-019B960494DF}">
-              <a14:hiddenLine xmlns:a14="http://schemas.microsoft.com/office/drawing/2010/main" xmlns="" w="9525">
+              <a14:hiddenLine xmlns="" xmlns:a14="http://schemas.microsoft.com/office/drawing/2010/main" w="9525">
                 <a:solidFill>
                   <a:srgbClr val="000000"/>
                 </a:solidFill>
@@ -33734,7 +33731,7 @@
         </p:nvSpPr>
         <p:spPr bwMode="auto">
           <a:xfrm>
-            <a:off x="1278788" y="2010871"/>
+            <a:off x="1278788" y="1985836"/>
             <a:ext cx="8416925" cy="946150"/>
           </a:xfrm>
           <a:prstGeom prst="rect">
@@ -33746,14 +33743,14 @@
           </a:ln>
           <a:extLst>
             <a:ext uri="{909E8E84-426E-40dd-AFC4-6F175D3DCCD1}">
-              <a14:hiddenFill xmlns:a14="http://schemas.microsoft.com/office/drawing/2010/main" xmlns="">
+              <a14:hiddenFill xmlns="" xmlns:a14="http://schemas.microsoft.com/office/drawing/2010/main">
                 <a:solidFill>
                   <a:srgbClr val="FFFFFF"/>
                 </a:solidFill>
               </a14:hiddenFill>
             </a:ext>
             <a:ext uri="{91240B29-F687-4f45-9708-019B960494DF}">
-              <a14:hiddenLine xmlns:a14="http://schemas.microsoft.com/office/drawing/2010/main" xmlns="" w="12700" cap="sq">
+              <a14:hiddenLine xmlns="" xmlns:a14="http://schemas.microsoft.com/office/drawing/2010/main" w="12700" cap="sq">
                 <a:solidFill>
                   <a:srgbClr val="000000"/>
                 </a:solidFill>
@@ -33916,7 +33913,7 @@
           </a:ln>
           <a:extLst>
             <a:ext uri="{91240B29-F687-4f45-9708-019B960494DF}">
-              <a14:hiddenLine xmlns:a14="http://schemas.microsoft.com/office/drawing/2010/main" xmlns="" w="12700" cap="sq">
+              <a14:hiddenLine xmlns="" xmlns:a14="http://schemas.microsoft.com/office/drawing/2010/main" w="12700" cap="sq">
                 <a:solidFill>
                   <a:srgbClr val="000000"/>
                 </a:solidFill>
@@ -34111,14 +34108,14 @@
           </a:ln>
           <a:extLst>
             <a:ext uri="{909E8E84-426E-40dd-AFC4-6F175D3DCCD1}">
-              <a14:hiddenFill xmlns:a14="http://schemas.microsoft.com/office/drawing/2010/main" xmlns="">
+              <a14:hiddenFill xmlns="" xmlns:a14="http://schemas.microsoft.com/office/drawing/2010/main">
                 <a:solidFill>
                   <a:srgbClr val="FFFFFF"/>
                 </a:solidFill>
               </a14:hiddenFill>
             </a:ext>
             <a:ext uri="{91240B29-F687-4f45-9708-019B960494DF}">
-              <a14:hiddenLine xmlns:a14="http://schemas.microsoft.com/office/drawing/2010/main" xmlns="" w="12700" cap="sq">
+              <a14:hiddenLine xmlns="" xmlns:a14="http://schemas.microsoft.com/office/drawing/2010/main" w="12700" cap="sq">
                 <a:solidFill>
                   <a:srgbClr val="000000"/>
                 </a:solidFill>
@@ -34259,7 +34256,7 @@
         </p:nvSpPr>
         <p:spPr bwMode="auto">
           <a:xfrm>
-            <a:off x="3041651" y="5114837"/>
+            <a:off x="3442459" y="5114837"/>
             <a:ext cx="4089581" cy="1200329"/>
           </a:xfrm>
           <a:prstGeom prst="rect">
@@ -34273,7 +34270,7 @@
           </a:ln>
           <a:extLst>
             <a:ext uri="{91240B29-F687-4f45-9708-019B960494DF}">
-              <a14:hiddenLine xmlns:a14="http://schemas.microsoft.com/office/drawing/2010/main" xmlns="" w="12700" cap="sq">
+              <a14:hiddenLine xmlns="" xmlns:a14="http://schemas.microsoft.com/office/drawing/2010/main" w="12700" cap="sq">
                 <a:solidFill>
                   <a:srgbClr val="000000"/>
                 </a:solidFill>
@@ -34398,20 +34395,20 @@
           </a:lstStyle>
           <a:p>
             <a:r>
-              <a:rPr lang="en-US" sz="2400">
+              <a:rPr lang="en-US" sz="2400" dirty="0">
                 <a:latin typeface="Lucida Sans Typewriter" charset="0"/>
               </a:rPr>
               <a:t>&gt; filter even [1..10]</a:t>
             </a:r>
           </a:p>
           <a:p>
-            <a:endParaRPr lang="en-US" sz="2400">
+            <a:endParaRPr lang="en-US" sz="2400" dirty="0">
               <a:latin typeface="Lucida Sans Typewriter" charset="0"/>
             </a:endParaRPr>
           </a:p>
           <a:p>
             <a:r>
-              <a:rPr lang="en-US" sz="2400">
+              <a:rPr lang="en-US" sz="2400" dirty="0">
                 <a:latin typeface="Lucida Sans Typewriter" charset="0"/>
               </a:rPr>
               <a:t>[2,4,6,8,10]</a:t>
@@ -34767,14 +34764,14 @@
           <a:ln/>
           <a:extLst>
             <a:ext uri="{909E8E84-426E-40dd-AFC4-6F175D3DCCD1}">
-              <a14:hiddenFill xmlns:a14="http://schemas.microsoft.com/office/drawing/2010/main" xmlns="">
+              <a14:hiddenFill xmlns="" xmlns:a14="http://schemas.microsoft.com/office/drawing/2010/main">
                 <a:solidFill>
                   <a:srgbClr val="FFFFFF"/>
                 </a:solidFill>
               </a14:hiddenFill>
             </a:ext>
             <a:ext uri="{91240B29-F687-4f45-9708-019B960494DF}">
-              <a14:hiddenLine xmlns:a14="http://schemas.microsoft.com/office/drawing/2010/main" xmlns="" w="9525">
+              <a14:hiddenLine xmlns="" xmlns:a14="http://schemas.microsoft.com/office/drawing/2010/main" w="9525">
                 <a:solidFill>
                   <a:srgbClr val="000000"/>
                 </a:solidFill>
@@ -34915,7 +34912,7 @@
         </p:nvSpPr>
         <p:spPr bwMode="auto">
           <a:xfrm>
-            <a:off x="1946132" y="3477492"/>
+            <a:off x="2209006" y="3484386"/>
             <a:ext cx="7773987" cy="519112"/>
           </a:xfrm>
           <a:prstGeom prst="rect">
@@ -34927,14 +34924,14 @@
           </a:ln>
           <a:extLst>
             <a:ext uri="{909E8E84-426E-40dd-AFC4-6F175D3DCCD1}">
-              <a14:hiddenFill xmlns:a14="http://schemas.microsoft.com/office/drawing/2010/main" xmlns="">
+              <a14:hiddenFill xmlns="" xmlns:a14="http://schemas.microsoft.com/office/drawing/2010/main">
                 <a:solidFill>
                   <a:srgbClr val="FFFFFF"/>
                 </a:solidFill>
               </a14:hiddenFill>
             </a:ext>
             <a:ext uri="{91240B29-F687-4f45-9708-019B960494DF}">
-              <a14:hiddenLine xmlns:a14="http://schemas.microsoft.com/office/drawing/2010/main" xmlns="" w="12700" cap="sq">
+              <a14:hiddenLine xmlns="" xmlns:a14="http://schemas.microsoft.com/office/drawing/2010/main" w="12700" cap="sq">
                 <a:solidFill>
                   <a:srgbClr val="000000"/>
                 </a:solidFill>
@@ -35087,14 +35084,14 @@
           </a:ln>
           <a:extLst>
             <a:ext uri="{909E8E84-426E-40dd-AFC4-6F175D3DCCD1}">
-              <a14:hiddenFill xmlns:a14="http://schemas.microsoft.com/office/drawing/2010/main" xmlns="">
+              <a14:hiddenFill xmlns="" xmlns:a14="http://schemas.microsoft.com/office/drawing/2010/main">
                 <a:solidFill>
                   <a:srgbClr val="FFFFFF"/>
                 </a:solidFill>
               </a14:hiddenFill>
             </a:ext>
             <a:ext uri="{91240B29-F687-4f45-9708-019B960494DF}">
-              <a14:hiddenLine xmlns:a14="http://schemas.microsoft.com/office/drawing/2010/main" xmlns="" w="12700" cap="sq">
+              <a14:hiddenLine xmlns="" xmlns:a14="http://schemas.microsoft.com/office/drawing/2010/main" w="12700" cap="sq">
                 <a:solidFill>
                   <a:srgbClr val="000000"/>
                 </a:solidFill>
@@ -35235,8 +35232,8 @@
         </p:nvSpPr>
         <p:spPr bwMode="auto">
           <a:xfrm>
-            <a:off x="2644486" y="2404197"/>
-            <a:ext cx="6008688" cy="457200"/>
+            <a:off x="2770692" y="2470458"/>
+            <a:ext cx="6228846" cy="457200"/>
           </a:xfrm>
           <a:prstGeom prst="rect">
             <a:avLst/>
@@ -35249,7 +35246,7 @@
           </a:ln>
           <a:extLst>
             <a:ext uri="{91240B29-F687-4f45-9708-019B960494DF}">
-              <a14:hiddenLine xmlns:a14="http://schemas.microsoft.com/office/drawing/2010/main" xmlns="" w="12700" cap="sq">
+              <a14:hiddenLine xmlns="" xmlns:a14="http://schemas.microsoft.com/office/drawing/2010/main" w="12700" cap="sq">
                 <a:solidFill>
                   <a:srgbClr val="000000"/>
                 </a:solidFill>
@@ -35261,7 +35258,7 @@
           </a:extLst>
         </p:spPr>
         <p:txBody>
-          <a:bodyPr wrap="none" anchor="ctr">
+          <a:bodyPr wrap="square" anchor="ctr">
             <a:spAutoFit/>
           </a:bodyPr>
           <a:lstStyle>
@@ -35430,7 +35427,7 @@
         </p:nvSpPr>
         <p:spPr bwMode="auto">
           <a:xfrm>
-            <a:off x="2644486" y="4424653"/>
+            <a:off x="2770692" y="4411400"/>
             <a:ext cx="6261100" cy="1990725"/>
           </a:xfrm>
           <a:prstGeom prst="rect">
@@ -35444,7 +35441,7 @@
           </a:ln>
           <a:extLst>
             <a:ext uri="{91240B29-F687-4f45-9708-019B960494DF}">
-              <a14:hiddenLine xmlns:a14="http://schemas.microsoft.com/office/drawing/2010/main" xmlns="" w="12700" cap="sq">
+              <a14:hiddenLine xmlns="" xmlns:a14="http://schemas.microsoft.com/office/drawing/2010/main" w="12700" cap="sq">
                 <a:solidFill>
                   <a:srgbClr val="000000"/>
                 </a:solidFill>
@@ -35954,14 +35951,14 @@
           <a:ln/>
           <a:extLst>
             <a:ext uri="{909E8E84-426E-40dd-AFC4-6F175D3DCCD1}">
-              <a14:hiddenFill xmlns:a14="http://schemas.microsoft.com/office/drawing/2010/main" xmlns="">
+              <a14:hiddenFill xmlns="" xmlns:a14="http://schemas.microsoft.com/office/drawing/2010/main">
                 <a:solidFill>
                   <a:srgbClr val="FFFFFF"/>
                 </a:solidFill>
               </a14:hiddenFill>
             </a:ext>
             <a:ext uri="{91240B29-F687-4f45-9708-019B960494DF}">
-              <a14:hiddenLine xmlns:a14="http://schemas.microsoft.com/office/drawing/2010/main" xmlns="" w="9525">
+              <a14:hiddenLine xmlns="" xmlns:a14="http://schemas.microsoft.com/office/drawing/2010/main" w="9525">
                 <a:solidFill>
                   <a:srgbClr val="000000"/>
                 </a:solidFill>
@@ -36114,14 +36111,14 @@
           </a:ln>
           <a:extLst>
             <a:ext uri="{909E8E84-426E-40dd-AFC4-6F175D3DCCD1}">
-              <a14:hiddenFill xmlns:a14="http://schemas.microsoft.com/office/drawing/2010/main" xmlns="">
+              <a14:hiddenFill xmlns="" xmlns:a14="http://schemas.microsoft.com/office/drawing/2010/main">
                 <a:solidFill>
                   <a:srgbClr val="FFFFFF"/>
                 </a:solidFill>
               </a14:hiddenFill>
             </a:ext>
             <a:ext uri="{91240B29-F687-4f45-9708-019B960494DF}">
-              <a14:hiddenLine xmlns:a14="http://schemas.microsoft.com/office/drawing/2010/main" xmlns="" w="12700" cap="sq">
+              <a14:hiddenLine xmlns="" xmlns:a14="http://schemas.microsoft.com/office/drawing/2010/main" w="12700" cap="sq">
                 <a:solidFill>
                   <a:srgbClr val="000000"/>
                 </a:solidFill>
@@ -36276,7 +36273,7 @@
           </a:ln>
           <a:extLst>
             <a:ext uri="{91240B29-F687-4f45-9708-019B960494DF}">
-              <a14:hiddenLine xmlns:a14="http://schemas.microsoft.com/office/drawing/2010/main" xmlns="" w="12700" cap="sq">
+              <a14:hiddenLine xmlns="" xmlns:a14="http://schemas.microsoft.com/office/drawing/2010/main" w="12700" cap="sq">
                 <a:solidFill>
                   <a:srgbClr val="000000"/>
                 </a:solidFill>
@@ -36494,7 +36491,7 @@
           </a:ln>
           <a:extLst>
             <a:ext uri="{909E8E84-426E-40dd-AFC4-6F175D3DCCD1}">
-              <a14:hiddenFill xmlns:a14="http://schemas.microsoft.com/office/drawing/2010/main" xmlns="">
+              <a14:hiddenFill xmlns="" xmlns:a14="http://schemas.microsoft.com/office/drawing/2010/main">
                 <a:solidFill>
                   <a:srgbClr val="FFFFFF"/>
                 </a:solidFill>
@@ -36566,14 +36563,14 @@
           <a:ln/>
           <a:extLst>
             <a:ext uri="{909E8E84-426E-40dd-AFC4-6F175D3DCCD1}">
-              <a14:hiddenFill xmlns:a14="http://schemas.microsoft.com/office/drawing/2010/main" xmlns="">
+              <a14:hiddenFill xmlns="" xmlns:a14="http://schemas.microsoft.com/office/drawing/2010/main">
                 <a:solidFill>
                   <a:srgbClr val="FFFFFF"/>
                 </a:solidFill>
               </a14:hiddenFill>
             </a:ext>
             <a:ext uri="{91240B29-F687-4f45-9708-019B960494DF}">
-              <a14:hiddenLine xmlns:a14="http://schemas.microsoft.com/office/drawing/2010/main" xmlns="" w="9525">
+              <a14:hiddenLine xmlns="" xmlns:a14="http://schemas.microsoft.com/office/drawing/2010/main" w="9525">
                 <a:solidFill>
                   <a:srgbClr val="000000"/>
                 </a:solidFill>
@@ -36726,14 +36723,14 @@
           </a:ln>
           <a:extLst>
             <a:ext uri="{909E8E84-426E-40dd-AFC4-6F175D3DCCD1}">
-              <a14:hiddenFill xmlns:a14="http://schemas.microsoft.com/office/drawing/2010/main" xmlns="">
+              <a14:hiddenFill xmlns="" xmlns:a14="http://schemas.microsoft.com/office/drawing/2010/main">
                 <a:solidFill>
                   <a:srgbClr val="FFFFFF"/>
                 </a:solidFill>
               </a14:hiddenFill>
             </a:ext>
             <a:ext uri="{91240B29-F687-4f45-9708-019B960494DF}">
-              <a14:hiddenLine xmlns:a14="http://schemas.microsoft.com/office/drawing/2010/main" xmlns="" w="12700" cap="sq">
+              <a14:hiddenLine xmlns="" xmlns:a14="http://schemas.microsoft.com/office/drawing/2010/main" w="12700" cap="sq">
                 <a:solidFill>
                   <a:srgbClr val="000000"/>
                 </a:solidFill>
@@ -36888,7 +36885,7 @@
           </a:ln>
           <a:extLst>
             <a:ext uri="{91240B29-F687-4f45-9708-019B960494DF}">
-              <a14:hiddenLine xmlns:a14="http://schemas.microsoft.com/office/drawing/2010/main" xmlns="" w="12700" cap="sq">
+              <a14:hiddenLine xmlns="" xmlns:a14="http://schemas.microsoft.com/office/drawing/2010/main" w="12700" cap="sq">
                 <a:solidFill>
                   <a:srgbClr val="000000"/>
                 </a:solidFill>
@@ -37070,7 +37067,7 @@
         </p:nvSpPr>
         <p:spPr bwMode="auto">
           <a:xfrm>
-            <a:off x="2283406" y="5519643"/>
+            <a:off x="2283406" y="5534000"/>
             <a:ext cx="4603750" cy="968375"/>
           </a:xfrm>
           <a:prstGeom prst="rect">
@@ -37084,7 +37081,7 @@
           </a:ln>
           <a:extLst>
             <a:ext uri="{91240B29-F687-4f45-9708-019B960494DF}">
-              <a14:hiddenLine xmlns:a14="http://schemas.microsoft.com/office/drawing/2010/main" xmlns="" w="12700" cap="sq">
+              <a14:hiddenLine xmlns="" xmlns:a14="http://schemas.microsoft.com/office/drawing/2010/main" w="12700" cap="sq">
                 <a:solidFill>
                   <a:srgbClr val="000000"/>
                 </a:solidFill>
@@ -37280,7 +37277,7 @@
           </a:ln>
           <a:extLst>
             <a:ext uri="{91240B29-F687-4f45-9708-019B960494DF}">
-              <a14:hiddenLine xmlns:a14="http://schemas.microsoft.com/office/drawing/2010/main" xmlns="" w="12700" cap="sq">
+              <a14:hiddenLine xmlns="" xmlns:a14="http://schemas.microsoft.com/office/drawing/2010/main" w="12700" cap="sq">
                 <a:solidFill>
                   <a:srgbClr val="000000"/>
                 </a:solidFill>
@@ -37485,7 +37482,7 @@
           </a:ln>
           <a:extLst>
             <a:ext uri="{909E8E84-426E-40dd-AFC4-6F175D3DCCD1}">
-              <a14:hiddenFill xmlns:a14="http://schemas.microsoft.com/office/drawing/2010/main" xmlns="">
+              <a14:hiddenFill xmlns="" xmlns:a14="http://schemas.microsoft.com/office/drawing/2010/main">
                 <a:solidFill>
                   <a:srgbClr val="FFFFFF"/>
                 </a:solidFill>
@@ -37561,7 +37558,7 @@
           </a:ln>
           <a:extLst>
             <a:ext uri="{909E8E84-426E-40dd-AFC4-6F175D3DCCD1}">
-              <a14:hiddenFill xmlns:a14="http://schemas.microsoft.com/office/drawing/2010/main" xmlns="">
+              <a14:hiddenFill xmlns="" xmlns:a14="http://schemas.microsoft.com/office/drawing/2010/main">
                 <a:solidFill>
                   <a:srgbClr val="FFFFFF"/>
                 </a:solidFill>
@@ -37641,7 +37638,7 @@
           </a:ln>
           <a:extLst>
             <a:ext uri="{909E8E84-426E-40dd-AFC4-6F175D3DCCD1}">
-              <a14:hiddenFill xmlns:a14="http://schemas.microsoft.com/office/drawing/2010/main" xmlns="">
+              <a14:hiddenFill xmlns="" xmlns:a14="http://schemas.microsoft.com/office/drawing/2010/main">
                 <a:solidFill>
                   <a:srgbClr val="FFFFFF"/>
                 </a:solidFill>
@@ -37981,7 +37978,7 @@
                             </p:stCondLst>
                             <p:childTnLst>
                               <p:par>
-                                <p:cTn id="23" presetID="2" presetClass="entr" presetSubtype="4" fill="hold" nodeType="clickEffect">
+                                <p:cTn id="23" presetID="2" presetClass="entr" presetSubtype="4" fill="hold" grpId="0" nodeType="clickEffect">
                                   <p:stCondLst>
                                     <p:cond delay="0"/>
                                   </p:stCondLst>
@@ -37989,6 +37986,85 @@
                                     <p:set>
                                       <p:cBhvr>
                                         <p:cTn id="24" dur="1" fill="hold">
+                                          <p:stCondLst>
+                                            <p:cond delay="0"/>
+                                          </p:stCondLst>
+                                        </p:cTn>
+                                        <p:tgtEl>
+                                          <p:spTgt spid="23556">
+                                            <p:bg/>
+                                          </p:spTgt>
+                                        </p:tgtEl>
+                                        <p:attrNameLst>
+                                          <p:attrName>style.visibility</p:attrName>
+                                        </p:attrNameLst>
+                                      </p:cBhvr>
+                                      <p:to>
+                                        <p:strVal val="visible"/>
+                                      </p:to>
+                                    </p:set>
+                                    <p:anim calcmode="lin" valueType="num">
+                                      <p:cBhvr additive="base">
+                                        <p:cTn id="25" dur="500" fill="hold"/>
+                                        <p:tgtEl>
+                                          <p:spTgt spid="23556">
+                                            <p:bg/>
+                                          </p:spTgt>
+                                        </p:tgtEl>
+                                        <p:attrNameLst>
+                                          <p:attrName>ppt_x</p:attrName>
+                                        </p:attrNameLst>
+                                      </p:cBhvr>
+                                      <p:tavLst>
+                                        <p:tav tm="0">
+                                          <p:val>
+                                            <p:strVal val="#ppt_x"/>
+                                          </p:val>
+                                        </p:tav>
+                                        <p:tav tm="100000">
+                                          <p:val>
+                                            <p:strVal val="#ppt_x"/>
+                                          </p:val>
+                                        </p:tav>
+                                      </p:tavLst>
+                                    </p:anim>
+                                    <p:anim calcmode="lin" valueType="num">
+                                      <p:cBhvr additive="base">
+                                        <p:cTn id="26" dur="500" fill="hold"/>
+                                        <p:tgtEl>
+                                          <p:spTgt spid="23556">
+                                            <p:bg/>
+                                          </p:spTgt>
+                                        </p:tgtEl>
+                                        <p:attrNameLst>
+                                          <p:attrName>ppt_y</p:attrName>
+                                        </p:attrNameLst>
+                                      </p:cBhvr>
+                                      <p:tavLst>
+                                        <p:tav tm="0">
+                                          <p:val>
+                                            <p:strVal val="1+#ppt_h/2"/>
+                                          </p:val>
+                                        </p:tav>
+                                        <p:tav tm="100000">
+                                          <p:val>
+                                            <p:strVal val="#ppt_y"/>
+                                          </p:val>
+                                        </p:tav>
+                                      </p:tavLst>
+                                    </p:anim>
+                                  </p:childTnLst>
+                                </p:cTn>
+                              </p:par>
+                              <p:par>
+                                <p:cTn id="27" presetID="2" presetClass="entr" presetSubtype="4" fill="hold" grpId="0" nodeType="withEffect">
+                                  <p:stCondLst>
+                                    <p:cond delay="0"/>
+                                  </p:stCondLst>
+                                  <p:childTnLst>
+                                    <p:set>
+                                      <p:cBhvr>
+                                        <p:cTn id="28" dur="1" fill="hold">
                                           <p:stCondLst>
                                             <p:cond delay="0"/>
                                           </p:stCondLst>
@@ -38010,7 +38086,7 @@
                                     </p:set>
                                     <p:anim calcmode="lin" valueType="num">
                                       <p:cBhvr additive="base">
-                                        <p:cTn id="25" dur="500" fill="hold"/>
+                                        <p:cTn id="29" dur="500" fill="hold"/>
                                         <p:tgtEl>
                                           <p:spTgt spid="23556">
                                             <p:txEl>
@@ -38037,11 +38113,96 @@
                                     </p:anim>
                                     <p:anim calcmode="lin" valueType="num">
                                       <p:cBhvr additive="base">
-                                        <p:cTn id="26" dur="500" fill="hold"/>
+                                        <p:cTn id="30" dur="500" fill="hold"/>
                                         <p:tgtEl>
                                           <p:spTgt spid="23556">
                                             <p:txEl>
                                               <p:pRg st="0" end="0"/>
+                                            </p:txEl>
+                                          </p:spTgt>
+                                        </p:tgtEl>
+                                        <p:attrNameLst>
+                                          <p:attrName>ppt_y</p:attrName>
+                                        </p:attrNameLst>
+                                      </p:cBhvr>
+                                      <p:tavLst>
+                                        <p:tav tm="0">
+                                          <p:val>
+                                            <p:strVal val="1+#ppt_h/2"/>
+                                          </p:val>
+                                        </p:tav>
+                                        <p:tav tm="100000">
+                                          <p:val>
+                                            <p:strVal val="#ppt_y"/>
+                                          </p:val>
+                                        </p:tav>
+                                      </p:tavLst>
+                                    </p:anim>
+                                  </p:childTnLst>
+                                </p:cTn>
+                              </p:par>
+                              <p:par>
+                                <p:cTn id="31" presetID="2" presetClass="entr" presetSubtype="4" fill="hold" grpId="0" nodeType="withEffect">
+                                  <p:stCondLst>
+                                    <p:cond delay="0"/>
+                                  </p:stCondLst>
+                                  <p:childTnLst>
+                                    <p:set>
+                                      <p:cBhvr>
+                                        <p:cTn id="32" dur="1" fill="hold">
+                                          <p:stCondLst>
+                                            <p:cond delay="0"/>
+                                          </p:stCondLst>
+                                        </p:cTn>
+                                        <p:tgtEl>
+                                          <p:spTgt spid="23556">
+                                            <p:txEl>
+                                              <p:pRg st="1" end="1"/>
+                                            </p:txEl>
+                                          </p:spTgt>
+                                        </p:tgtEl>
+                                        <p:attrNameLst>
+                                          <p:attrName>style.visibility</p:attrName>
+                                        </p:attrNameLst>
+                                      </p:cBhvr>
+                                      <p:to>
+                                        <p:strVal val="visible"/>
+                                      </p:to>
+                                    </p:set>
+                                    <p:anim calcmode="lin" valueType="num">
+                                      <p:cBhvr additive="base">
+                                        <p:cTn id="33" dur="500" fill="hold"/>
+                                        <p:tgtEl>
+                                          <p:spTgt spid="23556">
+                                            <p:txEl>
+                                              <p:pRg st="1" end="1"/>
+                                            </p:txEl>
+                                          </p:spTgt>
+                                        </p:tgtEl>
+                                        <p:attrNameLst>
+                                          <p:attrName>ppt_x</p:attrName>
+                                        </p:attrNameLst>
+                                      </p:cBhvr>
+                                      <p:tavLst>
+                                        <p:tav tm="0">
+                                          <p:val>
+                                            <p:strVal val="#ppt_x"/>
+                                          </p:val>
+                                        </p:tav>
+                                        <p:tav tm="100000">
+                                          <p:val>
+                                            <p:strVal val="#ppt_x"/>
+                                          </p:val>
+                                        </p:tav>
+                                      </p:tavLst>
+                                    </p:anim>
+                                    <p:anim calcmode="lin" valueType="num">
+                                      <p:cBhvr additive="base">
+                                        <p:cTn id="34" dur="500" fill="hold"/>
+                                        <p:tgtEl>
+                                          <p:spTgt spid="23556">
+                                            <p:txEl>
+                                              <p:pRg st="1" end="1"/>
                                             </p:txEl>
                                           </p:spTgt>
                                         </p:tgtEl>
@@ -38072,26 +38233,26 @@
                     </p:cTn>
                   </p:par>
                   <p:par>
-                    <p:cTn id="27" fill="hold">
+                    <p:cTn id="35" fill="hold">
                       <p:stCondLst>
                         <p:cond delay="indefinite"/>
                       </p:stCondLst>
                       <p:childTnLst>
                         <p:par>
-                          <p:cTn id="28" fill="hold">
+                          <p:cTn id="36" fill="hold">
                             <p:stCondLst>
                               <p:cond delay="0"/>
                             </p:stCondLst>
                             <p:childTnLst>
                               <p:par>
-                                <p:cTn id="29" presetID="2" presetClass="entr" presetSubtype="4" fill="hold" grpId="0" nodeType="clickEffect">
+                                <p:cTn id="37" presetID="2" presetClass="entr" presetSubtype="4" fill="hold" grpId="0" nodeType="clickEffect">
                                   <p:stCondLst>
                                     <p:cond delay="0"/>
                                   </p:stCondLst>
                                   <p:childTnLst>
                                     <p:set>
                                       <p:cBhvr>
-                                        <p:cTn id="30" dur="1" fill="hold">
+                                        <p:cTn id="38" dur="1" fill="hold">
                                           <p:stCondLst>
                                             <p:cond delay="0"/>
                                           </p:stCondLst>
@@ -38109,7 +38270,7 @@
                                     </p:set>
                                     <p:anim calcmode="lin" valueType="num">
                                       <p:cBhvr additive="base">
-                                        <p:cTn id="31" dur="500" fill="hold"/>
+                                        <p:cTn id="39" dur="500" fill="hold"/>
                                         <p:tgtEl>
                                           <p:spTgt spid="23560"/>
                                         </p:tgtEl>
@@ -38132,7 +38293,7 @@
                                     </p:anim>
                                     <p:anim calcmode="lin" valueType="num">
                                       <p:cBhvr additive="base">
-                                        <p:cTn id="32" dur="500" fill="hold"/>
+                                        <p:cTn id="40" dur="500" fill="hold"/>
                                         <p:tgtEl>
                                           <p:spTgt spid="23560"/>
                                         </p:tgtEl>
@@ -38184,6 +38345,7 @@
       </p:par>
     </p:tnLst>
     <p:bldLst>
+      <p:bldP spid="23556" grpId="0" uiExpand="1" build="allAtOnce" animBg="1"/>
       <p:bldP spid="23557" grpId="0" animBg="1"/>
       <p:bldP spid="23558" grpId="0" animBg="1"/>
       <p:bldP spid="23559" grpId="0" animBg="1"/>

</xml_diff>